<commit_message>
feat: initialize Foma code viewer application with lesson modules and content scripts
</commit_message>
<xml_diff>
--- a/05. step by step 2026 & 2027/01. frontend/webinar-03-flexbox-grid-cards/вебинар 3.pptx
+++ b/05. step by step 2026 & 2027/01. frontend/webinar-03-flexbox-grid-cards/вебинар 3.pptx
@@ -34,7 +34,6 @@
     <p:sldId id="316" r:id="rId78"/>
     <p:sldId id="317" r:id="rId79"/>
     <p:sldId id="318" r:id="rId80"/>
-    <p:sldId id="319" r:id="rId81"/>
     <p:sldId id="260" r:id="rId27"/>
     <p:sldId id="274" r:id="rId28"/>
   </p:sldIdLst>
@@ -22192,57 +22191,6 @@
           </a:p>
         </p:txBody>
       </p:sp>
-      <p:sp>
-        <p:nvSpPr>
-          <p:cNvPr id="26" name="Rounded Rectangle 25"/>
-          <p:cNvSpPr/>
-          <p:nvPr/>
-        </p:nvSpPr>
-        <p:spPr>
-          <a:xfrm>
-            <a:off x="1353820" y="4343400"/>
-            <a:ext cx="5905500" cy="330200"/>
-          </a:xfrm>
-          <a:prstGeom prst="roundRect">
-            <a:avLst>
-              <a:gd name="adj" fmla="val 25000"/>
-            </a:avLst>
-          </a:prstGeom>
-          <a:solidFill>
-            <a:srgbClr val="FAFAF9"/>
-          </a:solidFill>
-          <a:ln w="12700">
-            <a:solidFill>
-              <a:srgbClr val="FDBA74"/>
-            </a:solidFill>
-          </a:ln>
-        </p:spPr>
-        <p:txBody>
-          <a:bodyPr rtlCol="0" anchor="ctr" wrap="none" lIns="152400" tIns="50800" bIns="0" rIns="101600"/>
-          <a:lstStyle/>
-          <a:p>
-            <a:pPr algn="l"/>
-            <a:r>
-              <a:rPr sz="850" b="1">
-                <a:solidFill>
-                  <a:srgbClr val="FE6002"/>
-                </a:solidFill>
-                <a:latin typeface="Montserrat"/>
-              </a:rPr>
-              <a:t>РЕЗУЛЬТАТ: </a:t>
-            </a:r>
-            <a:r>
-              <a:rPr sz="850" b="0">
-                <a:solidFill>
-                  <a:srgbClr val="333333"/>
-                </a:solidFill>
-                <a:latin typeface="Inter"/>
-              </a:rPr>
-              <a:t>Адаптивная секция популярных предложений с переиспользуемыми компонентами.</a:t>
-            </a:r>
-          </a:p>
-        </p:txBody>
-      </p:sp>
     </p:spTree>
   </p:cSld>
   <p:clrMapOvr>
@@ -30252,7 +30200,7 @@
         </p:nvSpPr>
         <p:spPr>
           <a:xfrm>
-            <a:off x="4749800" y="2025650"/>
+            <a:off x="4749800" y="2051050"/>
             <a:ext cx="82550" cy="82550"/>
           </a:xfrm>
           <a:prstGeom prst="roundRect">
@@ -30283,7 +30231,7 @@
         </p:nvSpPr>
         <p:spPr>
           <a:xfrm>
-            <a:off x="4940300" y="1981200"/>
+            <a:off x="4940300" y="2006600"/>
             <a:ext cx="3898900" cy="609600"/>
           </a:xfrm>
           <a:prstGeom prst="rect">
@@ -30341,7 +30289,7 @@
         </p:nvSpPr>
         <p:spPr>
           <a:xfrm>
-            <a:off x="4749800" y="2813050"/>
+            <a:off x="4749800" y="2863850"/>
             <a:ext cx="82550" cy="82550"/>
           </a:xfrm>
           <a:prstGeom prst="roundRect">
@@ -30372,7 +30320,7 @@
         </p:nvSpPr>
         <p:spPr>
           <a:xfrm>
-            <a:off x="4940300" y="2768600"/>
+            <a:off x="4940300" y="2819400"/>
             <a:ext cx="3898900" cy="609600"/>
           </a:xfrm>
           <a:prstGeom prst="rect">
@@ -30430,7 +30378,7 @@
         </p:nvSpPr>
         <p:spPr>
           <a:xfrm>
-            <a:off x="4749800" y="3600450"/>
+            <a:off x="4749800" y="3676650"/>
             <a:ext cx="82550" cy="82550"/>
           </a:xfrm>
           <a:prstGeom prst="roundRect">
@@ -30461,7 +30409,7 @@
         </p:nvSpPr>
         <p:spPr>
           <a:xfrm>
-            <a:off x="4940300" y="3556000"/>
+            <a:off x="4940300" y="3632200"/>
             <a:ext cx="3898900" cy="609600"/>
           </a:xfrm>
           <a:prstGeom prst="rect">
@@ -31450,7 +31398,7 @@
         </p:nvSpPr>
         <p:spPr>
           <a:xfrm>
-            <a:off x="4749800" y="2025650"/>
+            <a:off x="4749800" y="2051050"/>
             <a:ext cx="82550" cy="82550"/>
           </a:xfrm>
           <a:prstGeom prst="roundRect">
@@ -31481,7 +31429,7 @@
         </p:nvSpPr>
         <p:spPr>
           <a:xfrm>
-            <a:off x="4940300" y="1981200"/>
+            <a:off x="4940300" y="2006600"/>
             <a:ext cx="3898900" cy="609600"/>
           </a:xfrm>
           <a:prstGeom prst="rect">
@@ -31539,7 +31487,7 @@
         </p:nvSpPr>
         <p:spPr>
           <a:xfrm>
-            <a:off x="4749800" y="2813050"/>
+            <a:off x="4749800" y="2863850"/>
             <a:ext cx="82550" cy="82550"/>
           </a:xfrm>
           <a:prstGeom prst="roundRect">
@@ -31570,7 +31518,7 @@
         </p:nvSpPr>
         <p:spPr>
           <a:xfrm>
-            <a:off x="4940300" y="2768600"/>
+            <a:off x="4940300" y="2819400"/>
             <a:ext cx="3898900" cy="609600"/>
           </a:xfrm>
           <a:prstGeom prst="rect">
@@ -31628,7 +31576,7 @@
         </p:nvSpPr>
         <p:spPr>
           <a:xfrm>
-            <a:off x="4749800" y="3600450"/>
+            <a:off x="4749800" y="3676650"/>
             <a:ext cx="82550" cy="82550"/>
           </a:xfrm>
           <a:prstGeom prst="roundRect">
@@ -31659,7 +31607,7 @@
         </p:nvSpPr>
         <p:spPr>
           <a:xfrm>
-            <a:off x="4940300" y="3556000"/>
+            <a:off x="4940300" y="3632200"/>
             <a:ext cx="3898900" cy="609600"/>
           </a:xfrm>
           <a:prstGeom prst="rect">
@@ -35298,7 +35246,7 @@
         </p:nvSpPr>
         <p:spPr>
           <a:xfrm>
-            <a:off x="4749800" y="2025650"/>
+            <a:off x="4749800" y="2051050"/>
             <a:ext cx="82550" cy="82550"/>
           </a:xfrm>
           <a:prstGeom prst="roundRect">
@@ -35329,7 +35277,7 @@
         </p:nvSpPr>
         <p:spPr>
           <a:xfrm>
-            <a:off x="4940300" y="1981200"/>
+            <a:off x="4940300" y="2006600"/>
             <a:ext cx="3898900" cy="609600"/>
           </a:xfrm>
           <a:prstGeom prst="rect">
@@ -35387,7 +35335,7 @@
         </p:nvSpPr>
         <p:spPr>
           <a:xfrm>
-            <a:off x="4749800" y="2813050"/>
+            <a:off x="4749800" y="2863850"/>
             <a:ext cx="82550" cy="82550"/>
           </a:xfrm>
           <a:prstGeom prst="roundRect">
@@ -35418,7 +35366,7 @@
         </p:nvSpPr>
         <p:spPr>
           <a:xfrm>
-            <a:off x="4940300" y="2768600"/>
+            <a:off x="4940300" y="2819400"/>
             <a:ext cx="3898900" cy="609600"/>
           </a:xfrm>
           <a:prstGeom prst="rect">
@@ -35476,7 +35424,7 @@
         </p:nvSpPr>
         <p:spPr>
           <a:xfrm>
-            <a:off x="4749800" y="3600450"/>
+            <a:off x="4749800" y="3676650"/>
             <a:ext cx="82550" cy="82550"/>
           </a:xfrm>
           <a:prstGeom prst="roundRect">
@@ -35507,7 +35455,7 @@
         </p:nvSpPr>
         <p:spPr>
           <a:xfrm>
-            <a:off x="4940300" y="3556000"/>
+            <a:off x="4940300" y="3632200"/>
             <a:ext cx="3898900" cy="609600"/>
           </a:xfrm>
           <a:prstGeom prst="rect">
@@ -36496,7 +36444,7 @@
         </p:nvSpPr>
         <p:spPr>
           <a:xfrm>
-            <a:off x="4749800" y="1987550"/>
+            <a:off x="4749800" y="2012950"/>
             <a:ext cx="82550" cy="82550"/>
           </a:xfrm>
           <a:prstGeom prst="roundRect">
@@ -36527,7 +36475,7 @@
         </p:nvSpPr>
         <p:spPr>
           <a:xfrm>
-            <a:off x="4940300" y="1943100"/>
+            <a:off x="4940300" y="1968500"/>
             <a:ext cx="3898900" cy="609600"/>
           </a:xfrm>
           <a:prstGeom prst="rect">
@@ -36585,7 +36533,7 @@
         </p:nvSpPr>
         <p:spPr>
           <a:xfrm>
-            <a:off x="4749800" y="2774950"/>
+            <a:off x="4749800" y="2825750"/>
             <a:ext cx="82550" cy="82550"/>
           </a:xfrm>
           <a:prstGeom prst="roundRect">
@@ -36616,7 +36564,7 @@
         </p:nvSpPr>
         <p:spPr>
           <a:xfrm>
-            <a:off x="4940300" y="2730500"/>
+            <a:off x="4940300" y="2781300"/>
             <a:ext cx="3898900" cy="609600"/>
           </a:xfrm>
           <a:prstGeom prst="rect">
@@ -36674,7 +36622,7 @@
         </p:nvSpPr>
         <p:spPr>
           <a:xfrm>
-            <a:off x="4749800" y="3562350"/>
+            <a:off x="4749800" y="3638550"/>
             <a:ext cx="82550" cy="82550"/>
           </a:xfrm>
           <a:prstGeom prst="roundRect">
@@ -36705,7 +36653,7 @@
         </p:nvSpPr>
         <p:spPr>
           <a:xfrm>
-            <a:off x="4940300" y="3517900"/>
+            <a:off x="4940300" y="3594100"/>
             <a:ext cx="3898900" cy="609600"/>
           </a:xfrm>
           <a:prstGeom prst="rect">
@@ -38614,7 +38562,7 @@
         </p:nvSpPr>
         <p:spPr>
           <a:xfrm>
-            <a:off x="4749800" y="2025650"/>
+            <a:off x="4749800" y="2051050"/>
             <a:ext cx="82550" cy="82550"/>
           </a:xfrm>
           <a:prstGeom prst="roundRect">
@@ -38645,7 +38593,7 @@
         </p:nvSpPr>
         <p:spPr>
           <a:xfrm>
-            <a:off x="4940300" y="1981200"/>
+            <a:off x="4940300" y="2006600"/>
             <a:ext cx="3898900" cy="609600"/>
           </a:xfrm>
           <a:prstGeom prst="rect">
@@ -38703,7 +38651,7 @@
         </p:nvSpPr>
         <p:spPr>
           <a:xfrm>
-            <a:off x="4749800" y="2813050"/>
+            <a:off x="4749800" y="2863850"/>
             <a:ext cx="82550" cy="82550"/>
           </a:xfrm>
           <a:prstGeom prst="roundRect">
@@ -38734,7 +38682,7 @@
         </p:nvSpPr>
         <p:spPr>
           <a:xfrm>
-            <a:off x="4940300" y="2768600"/>
+            <a:off x="4940300" y="2819400"/>
             <a:ext cx="3898900" cy="609600"/>
           </a:xfrm>
           <a:prstGeom prst="rect">
@@ -38792,7 +38740,7 @@
         </p:nvSpPr>
         <p:spPr>
           <a:xfrm>
-            <a:off x="4749800" y="3600450"/>
+            <a:off x="4749800" y="3676650"/>
             <a:ext cx="82550" cy="82550"/>
           </a:xfrm>
           <a:prstGeom prst="roundRect">
@@ -38823,7 +38771,7 @@
         </p:nvSpPr>
         <p:spPr>
           <a:xfrm>
-            <a:off x="4940300" y="3556000"/>
+            <a:off x="4940300" y="3632200"/>
             <a:ext cx="3898900" cy="609600"/>
           </a:xfrm>
           <a:prstGeom prst="rect">
@@ -39975,7 +39923,7 @@
         </p:nvSpPr>
         <p:spPr>
           <a:xfrm>
-            <a:off x="4749800" y="1987550"/>
+            <a:off x="4749800" y="2012950"/>
             <a:ext cx="82550" cy="82550"/>
           </a:xfrm>
           <a:prstGeom prst="roundRect">
@@ -40006,7 +39954,7 @@
         </p:nvSpPr>
         <p:spPr>
           <a:xfrm>
-            <a:off x="4940300" y="1943100"/>
+            <a:off x="4940300" y="1968500"/>
             <a:ext cx="3898900" cy="609600"/>
           </a:xfrm>
           <a:prstGeom prst="rect">
@@ -40064,7 +40012,7 @@
         </p:nvSpPr>
         <p:spPr>
           <a:xfrm>
-            <a:off x="4749800" y="2774950"/>
+            <a:off x="4749800" y="2825750"/>
             <a:ext cx="82550" cy="82550"/>
           </a:xfrm>
           <a:prstGeom prst="roundRect">
@@ -40095,7 +40043,7 @@
         </p:nvSpPr>
         <p:spPr>
           <a:xfrm>
-            <a:off x="4940300" y="2730500"/>
+            <a:off x="4940300" y="2781300"/>
             <a:ext cx="3898900" cy="609600"/>
           </a:xfrm>
           <a:prstGeom prst="rect">
@@ -40153,7 +40101,7 @@
         </p:nvSpPr>
         <p:spPr>
           <a:xfrm>
-            <a:off x="4749800" y="3562350"/>
+            <a:off x="4749800" y="3638550"/>
             <a:ext cx="82550" cy="82550"/>
           </a:xfrm>
           <a:prstGeom prst="roundRect">
@@ -40184,7 +40132,7 @@
         </p:nvSpPr>
         <p:spPr>
           <a:xfrm>
-            <a:off x="4940300" y="3517900"/>
+            <a:off x="4940300" y="3594100"/>
             <a:ext cx="3898900" cy="609600"/>
           </a:xfrm>
           <a:prstGeom prst="rect">
@@ -41297,7 +41245,7 @@
         </p:nvSpPr>
         <p:spPr>
           <a:xfrm>
-            <a:off x="4749800" y="2025650"/>
+            <a:off x="4749800" y="2051050"/>
             <a:ext cx="82550" cy="82550"/>
           </a:xfrm>
           <a:prstGeom prst="roundRect">
@@ -41328,7 +41276,7 @@
         </p:nvSpPr>
         <p:spPr>
           <a:xfrm>
-            <a:off x="4940300" y="1981200"/>
+            <a:off x="4940300" y="2006600"/>
             <a:ext cx="3898900" cy="609600"/>
           </a:xfrm>
           <a:prstGeom prst="rect">
@@ -41386,7 +41334,7 @@
         </p:nvSpPr>
         <p:spPr>
           <a:xfrm>
-            <a:off x="4749800" y="2813050"/>
+            <a:off x="4749800" y="2863850"/>
             <a:ext cx="82550" cy="82550"/>
           </a:xfrm>
           <a:prstGeom prst="roundRect">
@@ -41417,7 +41365,7 @@
         </p:nvSpPr>
         <p:spPr>
           <a:xfrm>
-            <a:off x="4940300" y="2768600"/>
+            <a:off x="4940300" y="2819400"/>
             <a:ext cx="3898900" cy="609600"/>
           </a:xfrm>
           <a:prstGeom prst="rect">
@@ -41475,7 +41423,7 @@
         </p:nvSpPr>
         <p:spPr>
           <a:xfrm>
-            <a:off x="4749800" y="3600450"/>
+            <a:off x="4749800" y="3676650"/>
             <a:ext cx="82550" cy="82550"/>
           </a:xfrm>
           <a:prstGeom prst="roundRect">
@@ -41506,7 +41454,7 @@
         </p:nvSpPr>
         <p:spPr>
           <a:xfrm>
-            <a:off x="4940300" y="3556000"/>
+            <a:off x="4940300" y="3632200"/>
             <a:ext cx="3898900" cy="609600"/>
           </a:xfrm>
           <a:prstGeom prst="rect">
@@ -42548,7 +42496,7 @@
         </p:nvSpPr>
         <p:spPr>
           <a:xfrm>
-            <a:off x="4749800" y="2025650"/>
+            <a:off x="4749800" y="2051050"/>
             <a:ext cx="82550" cy="82550"/>
           </a:xfrm>
           <a:prstGeom prst="roundRect">
@@ -42579,7 +42527,7 @@
         </p:nvSpPr>
         <p:spPr>
           <a:xfrm>
-            <a:off x="4940300" y="1981200"/>
+            <a:off x="4940300" y="2006600"/>
             <a:ext cx="3898900" cy="609600"/>
           </a:xfrm>
           <a:prstGeom prst="rect">
@@ -42637,7 +42585,7 @@
         </p:nvSpPr>
         <p:spPr>
           <a:xfrm>
-            <a:off x="4749800" y="2813050"/>
+            <a:off x="4749800" y="2863850"/>
             <a:ext cx="82550" cy="82550"/>
           </a:xfrm>
           <a:prstGeom prst="roundRect">
@@ -42668,7 +42616,7 @@
         </p:nvSpPr>
         <p:spPr>
           <a:xfrm>
-            <a:off x="4940300" y="2768600"/>
+            <a:off x="4940300" y="2819400"/>
             <a:ext cx="3898900" cy="609600"/>
           </a:xfrm>
           <a:prstGeom prst="rect">
@@ -42726,7 +42674,7 @@
         </p:nvSpPr>
         <p:spPr>
           <a:xfrm>
-            <a:off x="4749800" y="3600450"/>
+            <a:off x="4749800" y="3676650"/>
             <a:ext cx="82550" cy="82550"/>
           </a:xfrm>
           <a:prstGeom prst="roundRect">
@@ -42757,7 +42705,7 @@
         </p:nvSpPr>
         <p:spPr>
           <a:xfrm>
-            <a:off x="4940300" y="3556000"/>
+            <a:off x="4940300" y="3632200"/>
             <a:ext cx="3898900" cy="609600"/>
           </a:xfrm>
           <a:prstGeom prst="rect">
@@ -43830,7 +43778,7 @@
         </p:nvSpPr>
         <p:spPr>
           <a:xfrm>
-            <a:off x="4749800" y="1987550"/>
+            <a:off x="4749800" y="2012950"/>
             <a:ext cx="82550" cy="82550"/>
           </a:xfrm>
           <a:prstGeom prst="roundRect">
@@ -43861,7 +43809,7 @@
         </p:nvSpPr>
         <p:spPr>
           <a:xfrm>
-            <a:off x="4940300" y="1943100"/>
+            <a:off x="4940300" y="1968500"/>
             <a:ext cx="3898900" cy="609600"/>
           </a:xfrm>
           <a:prstGeom prst="rect">
@@ -43919,7 +43867,7 @@
         </p:nvSpPr>
         <p:spPr>
           <a:xfrm>
-            <a:off x="4749800" y="2774950"/>
+            <a:off x="4749800" y="2825750"/>
             <a:ext cx="82550" cy="82550"/>
           </a:xfrm>
           <a:prstGeom prst="roundRect">
@@ -43950,7 +43898,7 @@
         </p:nvSpPr>
         <p:spPr>
           <a:xfrm>
-            <a:off x="4940300" y="2730500"/>
+            <a:off x="4940300" y="2781300"/>
             <a:ext cx="3898900" cy="609600"/>
           </a:xfrm>
           <a:prstGeom prst="rect">
@@ -44008,7 +43956,7 @@
         </p:nvSpPr>
         <p:spPr>
           <a:xfrm>
-            <a:off x="4749800" y="3562350"/>
+            <a:off x="4749800" y="3638550"/>
             <a:ext cx="82550" cy="82550"/>
           </a:xfrm>
           <a:prstGeom prst="roundRect">
@@ -44039,7 +43987,7 @@
         </p:nvSpPr>
         <p:spPr>
           <a:xfrm>
-            <a:off x="4940300" y="3517900"/>
+            <a:off x="4940300" y="3594100"/>
             <a:ext cx="3898900" cy="609600"/>
           </a:xfrm>
           <a:prstGeom prst="rect">
@@ -44961,7 +44909,7 @@
         </p:nvSpPr>
         <p:spPr>
           <a:xfrm>
-            <a:off x="4749800" y="2025650"/>
+            <a:off x="4749800" y="2051050"/>
             <a:ext cx="82550" cy="82550"/>
           </a:xfrm>
           <a:prstGeom prst="roundRect">
@@ -44992,7 +44940,7 @@
         </p:nvSpPr>
         <p:spPr>
           <a:xfrm>
-            <a:off x="4940300" y="1981200"/>
+            <a:off x="4940300" y="2006600"/>
             <a:ext cx="3898900" cy="609600"/>
           </a:xfrm>
           <a:prstGeom prst="rect">
@@ -45050,7 +44998,7 @@
         </p:nvSpPr>
         <p:spPr>
           <a:xfrm>
-            <a:off x="4749800" y="2813050"/>
+            <a:off x="4749800" y="2863850"/>
             <a:ext cx="82550" cy="82550"/>
           </a:xfrm>
           <a:prstGeom prst="roundRect">
@@ -45081,7 +45029,7 @@
         </p:nvSpPr>
         <p:spPr>
           <a:xfrm>
-            <a:off x="4940300" y="2768600"/>
+            <a:off x="4940300" y="2819400"/>
             <a:ext cx="3898900" cy="609600"/>
           </a:xfrm>
           <a:prstGeom prst="rect">
@@ -45139,7 +45087,7 @@
         </p:nvSpPr>
         <p:spPr>
           <a:xfrm>
-            <a:off x="4749800" y="3600450"/>
+            <a:off x="4749800" y="3676650"/>
             <a:ext cx="82550" cy="82550"/>
           </a:xfrm>
           <a:prstGeom prst="roundRect">
@@ -45170,7 +45118,7 @@
         </p:nvSpPr>
         <p:spPr>
           <a:xfrm>
-            <a:off x="4940300" y="3556000"/>
+            <a:off x="4940300" y="3632200"/>
             <a:ext cx="3898900" cy="609600"/>
           </a:xfrm>
           <a:prstGeom prst="rect">
@@ -47409,7 +47357,7 @@
         </p:nvSpPr>
         <p:spPr>
           <a:xfrm>
-            <a:off x="4749800" y="2025650"/>
+            <a:off x="4749800" y="2051050"/>
             <a:ext cx="82550" cy="82550"/>
           </a:xfrm>
           <a:prstGeom prst="roundRect">
@@ -47440,7 +47388,7 @@
         </p:nvSpPr>
         <p:spPr>
           <a:xfrm>
-            <a:off x="4940300" y="1981200"/>
+            <a:off x="4940300" y="2006600"/>
             <a:ext cx="3898900" cy="609600"/>
           </a:xfrm>
           <a:prstGeom prst="rect">
@@ -47498,7 +47446,7 @@
         </p:nvSpPr>
         <p:spPr>
           <a:xfrm>
-            <a:off x="4749800" y="2813050"/>
+            <a:off x="4749800" y="2863850"/>
             <a:ext cx="82550" cy="82550"/>
           </a:xfrm>
           <a:prstGeom prst="roundRect">
@@ -47529,7 +47477,7 @@
         </p:nvSpPr>
         <p:spPr>
           <a:xfrm>
-            <a:off x="4940300" y="2768600"/>
+            <a:off x="4940300" y="2819400"/>
             <a:ext cx="3898900" cy="609600"/>
           </a:xfrm>
           <a:prstGeom prst="rect">
@@ -47587,7 +47535,7 @@
         </p:nvSpPr>
         <p:spPr>
           <a:xfrm>
-            <a:off x="4749800" y="3600450"/>
+            <a:off x="4749800" y="3676650"/>
             <a:ext cx="82550" cy="82550"/>
           </a:xfrm>
           <a:prstGeom prst="roundRect">
@@ -47618,7 +47566,7 @@
         </p:nvSpPr>
         <p:spPr>
           <a:xfrm>
-            <a:off x="4940300" y="3556000"/>
+            <a:off x="4940300" y="3632200"/>
             <a:ext cx="3898900" cy="609600"/>
           </a:xfrm>
           <a:prstGeom prst="rect">
@@ -48562,7 +48510,7 @@
         </p:nvSpPr>
         <p:spPr>
           <a:xfrm>
-            <a:off x="4749800" y="2025650"/>
+            <a:off x="4749800" y="2051050"/>
             <a:ext cx="82550" cy="82550"/>
           </a:xfrm>
           <a:prstGeom prst="roundRect">
@@ -48593,7 +48541,7 @@
         </p:nvSpPr>
         <p:spPr>
           <a:xfrm>
-            <a:off x="4940300" y="1981200"/>
+            <a:off x="4940300" y="2006600"/>
             <a:ext cx="3898900" cy="609600"/>
           </a:xfrm>
           <a:prstGeom prst="rect">
@@ -48651,7 +48599,7 @@
         </p:nvSpPr>
         <p:spPr>
           <a:xfrm>
-            <a:off x="4749800" y="2813050"/>
+            <a:off x="4749800" y="2863850"/>
             <a:ext cx="82550" cy="82550"/>
           </a:xfrm>
           <a:prstGeom prst="roundRect">
@@ -48682,7 +48630,7 @@
         </p:nvSpPr>
         <p:spPr>
           <a:xfrm>
-            <a:off x="4940300" y="2768600"/>
+            <a:off x="4940300" y="2819400"/>
             <a:ext cx="3898900" cy="609600"/>
           </a:xfrm>
           <a:prstGeom prst="rect">
@@ -48740,7 +48688,7 @@
         </p:nvSpPr>
         <p:spPr>
           <a:xfrm>
-            <a:off x="4749800" y="3600450"/>
+            <a:off x="4749800" y="3676650"/>
             <a:ext cx="82550" cy="82550"/>
           </a:xfrm>
           <a:prstGeom prst="roundRect">
@@ -48771,7 +48719,7 @@
         </p:nvSpPr>
         <p:spPr>
           <a:xfrm>
-            <a:off x="4940300" y="3556000"/>
+            <a:off x="4940300" y="3632200"/>
             <a:ext cx="3898900" cy="609600"/>
           </a:xfrm>
           <a:prstGeom prst="rect">
@@ -50041,7 +49989,7 @@
         </p:nvSpPr>
         <p:spPr>
           <a:xfrm>
-            <a:off x="4749800" y="1987550"/>
+            <a:off x="4749800" y="2012950"/>
             <a:ext cx="82550" cy="82550"/>
           </a:xfrm>
           <a:prstGeom prst="roundRect">
@@ -50072,7 +50020,7 @@
         </p:nvSpPr>
         <p:spPr>
           <a:xfrm>
-            <a:off x="4940300" y="1943100"/>
+            <a:off x="4940300" y="1968500"/>
             <a:ext cx="3898900" cy="609600"/>
           </a:xfrm>
           <a:prstGeom prst="rect">
@@ -50130,7 +50078,7 @@
         </p:nvSpPr>
         <p:spPr>
           <a:xfrm>
-            <a:off x="4749800" y="2774950"/>
+            <a:off x="4749800" y="2825750"/>
             <a:ext cx="82550" cy="82550"/>
           </a:xfrm>
           <a:prstGeom prst="roundRect">
@@ -50161,7 +50109,7 @@
         </p:nvSpPr>
         <p:spPr>
           <a:xfrm>
-            <a:off x="4940300" y="2730500"/>
+            <a:off x="4940300" y="2781300"/>
             <a:ext cx="3898900" cy="609600"/>
           </a:xfrm>
           <a:prstGeom prst="rect">
@@ -50219,7 +50167,7 @@
         </p:nvSpPr>
         <p:spPr>
           <a:xfrm>
-            <a:off x="4749800" y="3562350"/>
+            <a:off x="4749800" y="3638550"/>
             <a:ext cx="82550" cy="82550"/>
           </a:xfrm>
           <a:prstGeom prst="roundRect">
@@ -50250,7 +50198,7 @@
         </p:nvSpPr>
         <p:spPr>
           <a:xfrm>
-            <a:off x="4940300" y="3517900"/>
+            <a:off x="4940300" y="3594100"/>
             <a:ext cx="3898900" cy="609600"/>
           </a:xfrm>
           <a:prstGeom prst="rect">
@@ -51474,7 +51422,7 @@
         </p:nvSpPr>
         <p:spPr>
           <a:xfrm>
-            <a:off x="4749800" y="2025650"/>
+            <a:off x="4749800" y="2051050"/>
             <a:ext cx="82550" cy="82550"/>
           </a:xfrm>
           <a:prstGeom prst="roundRect">
@@ -51505,7 +51453,7 @@
         </p:nvSpPr>
         <p:spPr>
           <a:xfrm>
-            <a:off x="4940300" y="1981200"/>
+            <a:off x="4940300" y="2006600"/>
             <a:ext cx="3898900" cy="609600"/>
           </a:xfrm>
           <a:prstGeom prst="rect">
@@ -51563,7 +51511,7 @@
         </p:nvSpPr>
         <p:spPr>
           <a:xfrm>
-            <a:off x="4749800" y="2813050"/>
+            <a:off x="4749800" y="2863850"/>
             <a:ext cx="82550" cy="82550"/>
           </a:xfrm>
           <a:prstGeom prst="roundRect">
@@ -51594,7 +51542,7 @@
         </p:nvSpPr>
         <p:spPr>
           <a:xfrm>
-            <a:off x="4940300" y="2768600"/>
+            <a:off x="4940300" y="2819400"/>
             <a:ext cx="3898900" cy="609600"/>
           </a:xfrm>
           <a:prstGeom prst="rect">
@@ -51652,7 +51600,7 @@
         </p:nvSpPr>
         <p:spPr>
           <a:xfrm>
-            <a:off x="4749800" y="3600450"/>
+            <a:off x="4749800" y="3676650"/>
             <a:ext cx="82550" cy="82550"/>
           </a:xfrm>
           <a:prstGeom prst="roundRect">
@@ -51683,7 +51631,7 @@
         </p:nvSpPr>
         <p:spPr>
           <a:xfrm>
-            <a:off x="4940300" y="3556000"/>
+            <a:off x="4940300" y="3632200"/>
             <a:ext cx="3898900" cy="609600"/>
           </a:xfrm>
           <a:prstGeom prst="rect">
@@ -52562,7 +52510,7 @@
         </p:nvSpPr>
         <p:spPr>
           <a:xfrm>
-            <a:off x="4749800" y="2025650"/>
+            <a:off x="4749800" y="2051050"/>
             <a:ext cx="82550" cy="82550"/>
           </a:xfrm>
           <a:prstGeom prst="roundRect">
@@ -52593,7 +52541,7 @@
         </p:nvSpPr>
         <p:spPr>
           <a:xfrm>
-            <a:off x="4940300" y="1981200"/>
+            <a:off x="4940300" y="2006600"/>
             <a:ext cx="3898900" cy="609600"/>
           </a:xfrm>
           <a:prstGeom prst="rect">
@@ -52651,7 +52599,7 @@
         </p:nvSpPr>
         <p:spPr>
           <a:xfrm>
-            <a:off x="4749800" y="2813050"/>
+            <a:off x="4749800" y="2863850"/>
             <a:ext cx="82550" cy="82550"/>
           </a:xfrm>
           <a:prstGeom prst="roundRect">
@@ -52682,7 +52630,7 @@
         </p:nvSpPr>
         <p:spPr>
           <a:xfrm>
-            <a:off x="4940300" y="2768600"/>
+            <a:off x="4940300" y="2819400"/>
             <a:ext cx="3898900" cy="609600"/>
           </a:xfrm>
           <a:prstGeom prst="rect">
@@ -52740,7 +52688,7 @@
         </p:nvSpPr>
         <p:spPr>
           <a:xfrm>
-            <a:off x="4749800" y="3600450"/>
+            <a:off x="4749800" y="3676650"/>
             <a:ext cx="82550" cy="82550"/>
           </a:xfrm>
           <a:prstGeom prst="roundRect">
@@ -52771,7 +52719,7 @@
         </p:nvSpPr>
         <p:spPr>
           <a:xfrm>
-            <a:off x="4940300" y="3556000"/>
+            <a:off x="4940300" y="3632200"/>
             <a:ext cx="3898900" cy="609600"/>
           </a:xfrm>
           <a:prstGeom prst="rect">
@@ -52847,8 +52795,8 @@
         </p:nvSpPr>
         <p:spPr>
           <a:xfrm>
-            <a:off x="5694680" y="259079"/>
-            <a:ext cx="3195320" cy="287020"/>
+            <a:off x="5072380" y="259079"/>
+            <a:ext cx="3817620" cy="287020"/>
           </a:xfrm>
           <a:prstGeom prst="roundRect">
             <a:avLst>
@@ -52876,7 +52824,7 @@
                 </a:solidFill>
                 <a:latin typeface="Inter"/>
               </a:rPr>
-              <a:t>АДАПТИВНОСТЬ: ПЛАНШЕТЫ</a:t>
+              <a:t>АДАПТИВНОСТЬ: МЕДИА-ЗАПРОСЫ</a:t>
             </a:r>
           </a:p>
         </p:txBody>
@@ -52911,7 +52859,7 @@
                 </a:solidFill>
                 <a:latin typeface="Montserrat"/>
               </a:rPr>
-              <a:t>Как перестроить витрину из 3 колонок в 2 колонки на экране планшета?</a:t>
+              <a:t>Как перестроить витрину и шапку сайта под экраны планшетов и смартфонов?</a:t>
             </a:r>
           </a:p>
         </p:txBody>
@@ -52978,7 +52926,7 @@
                 </a:solidFill>
                 <a:latin typeface="Consolas"/>
               </a:rPr>
-              <a:t>📄 css/style.css (@media max-width: 768px)</a:t>
+              <a:t>📄 css/style.css (@media 768px &amp; 480px)</a:t>
             </a:r>
           </a:p>
         </p:txBody>
@@ -53048,6 +52996,28 @@
             <a:r>
               <a:rPr sz="800">
                 <a:solidFill>
+                  <a:srgbClr val="71717A"/>
+                </a:solidFill>
+                <a:latin typeface="Consolas"/>
+              </a:rPr>
+              <a:t>/* 1. Планшет (max-width: 768px): 2 колонки */</a:t>
+            </a:r>
+          </a:p>
+          <a:p>
+            <a:pPr>
+              <a:lnSpc>
+                <a:spcPct val="105000"/>
+              </a:lnSpc>
+              <a:spcBef>
+                <a:spcPts val="0"/>
+              </a:spcBef>
+              <a:spcAft>
+                <a:spcPts val="100"/>
+              </a:spcAft>
+            </a:pPr>
+            <a:r>
+              <a:rPr sz="800">
+                <a:solidFill>
                   <a:srgbClr val="38BDF8"/>
                 </a:solidFill>
                 <a:latin typeface="Consolas"/>
@@ -53088,11 +53058,148 @@
             <a:r>
               <a:rPr sz="800">
                 <a:solidFill>
+                  <a:srgbClr val="F472B6"/>
+                </a:solidFill>
+                <a:latin typeface="Consolas"/>
+              </a:rPr>
+              <a:t>  .container </a:t>
+            </a:r>
+            <a:r>
+              <a:rPr sz="800">
+                <a:solidFill>
+                  <a:srgbClr val="D4D4D8"/>
+                </a:solidFill>
+                <a:latin typeface="Consolas"/>
+              </a:rPr>
+              <a:t>{ width: 100%; padding: 0 16px; }</a:t>
+            </a:r>
+          </a:p>
+          <a:p>
+            <a:pPr>
+              <a:lnSpc>
+                <a:spcPct val="105000"/>
+              </a:lnSpc>
+              <a:spcBef>
+                <a:spcPts val="0"/>
+              </a:spcBef>
+              <a:spcAft>
+                <a:spcPts val="100"/>
+              </a:spcAft>
+            </a:pPr>
+            <a:r>
+              <a:rPr sz="800">
+                <a:solidFill>
+                  <a:srgbClr val="F472B6"/>
+                </a:solidFill>
+                <a:latin typeface="Consolas"/>
+              </a:rPr>
+              <a:t>  .room-card </a:t>
+            </a:r>
+            <a:r>
+              <a:rPr sz="800">
+                <a:solidFill>
+                  <a:srgbClr val="D4D4D8"/>
+                </a:solidFill>
+                <a:latin typeface="Consolas"/>
+              </a:rPr>
+              <a:t>{ width: calc(50% - 10px); }</a:t>
+            </a:r>
+          </a:p>
+          <a:p>
+            <a:pPr>
+              <a:lnSpc>
+                <a:spcPct val="105000"/>
+              </a:lnSpc>
+              <a:spcBef>
+                <a:spcPts val="0"/>
+              </a:spcBef>
+              <a:spcAft>
+                <a:spcPts val="100"/>
+              </a:spcAft>
+            </a:pPr>
+            <a:r>
+              <a:rPr sz="800">
+                <a:solidFill>
+                  <a:srgbClr val="F472B6"/>
+                </a:solidFill>
+                <a:latin typeface="Consolas"/>
+              </a:rPr>
+              <a:t>  .hero-title </a:t>
+            </a:r>
+            <a:r>
+              <a:rPr sz="800">
+                <a:solidFill>
+                  <a:srgbClr val="D4D4D8"/>
+                </a:solidFill>
+                <a:latin typeface="Consolas"/>
+              </a:rPr>
+              <a:t>{ font-size: 52px; line-height: 1.1; }</a:t>
+            </a:r>
+          </a:p>
+          <a:p>
+            <a:pPr>
+              <a:lnSpc>
+                <a:spcPct val="105000"/>
+              </a:lnSpc>
+              <a:spcBef>
+                <a:spcPts val="0"/>
+              </a:spcBef>
+              <a:spcAft>
+                <a:spcPts val="100"/>
+              </a:spcAft>
+            </a:pPr>
+            <a:r>
+              <a:rPr sz="800">
+                <a:solidFill>
+                  <a:srgbClr val="D4D4D8"/>
+                </a:solidFill>
+                <a:latin typeface="Consolas"/>
+              </a:rPr>
+              <a:t>}</a:t>
+            </a:r>
+          </a:p>
+          <a:p>
+            <a:pPr>
+              <a:lnSpc>
+                <a:spcPct val="105000"/>
+              </a:lnSpc>
+              <a:spcBef>
+                <a:spcPts val="0"/>
+              </a:spcBef>
+              <a:spcAft>
+                <a:spcPts val="100"/>
+              </a:spcAft>
+            </a:pPr>
+            <a:r>
+              <a:rPr sz="800">
+                <a:solidFill>
+                  <a:srgbClr val="D4D4D8"/>
+                </a:solidFill>
+                <a:latin typeface="Consolas"/>
+              </a:rPr>
+              <a:t/>
+            </a:r>
+          </a:p>
+          <a:p>
+            <a:pPr>
+              <a:lnSpc>
+                <a:spcPct val="105000"/>
+              </a:lnSpc>
+              <a:spcBef>
+                <a:spcPts val="0"/>
+              </a:spcBef>
+              <a:spcAft>
+                <a:spcPts val="100"/>
+              </a:spcAft>
+            </a:pPr>
+            <a:r>
+              <a:rPr sz="800">
+                <a:solidFill>
                   <a:srgbClr val="71717A"/>
                 </a:solidFill>
                 <a:latin typeface="Consolas"/>
               </a:rPr>
-              <a:t>  /* 1. Резиновый контейнер */</a:t>
+              <a:t>/* 2. Смартфон (max-width: 480px): 1 колонка */</a:t>
             </a:r>
           </a:p>
           <a:p>
@@ -53110,11 +53217,20 @@
             <a:r>
               <a:rPr sz="800">
                 <a:solidFill>
+                  <a:srgbClr val="38BDF8"/>
+                </a:solidFill>
+                <a:latin typeface="Consolas"/>
+              </a:rPr>
+              <a:t>@media </a:t>
+            </a:r>
+            <a:r>
+              <a:rPr sz="800">
+                <a:solidFill>
                   <a:srgbClr val="F472B6"/>
                 </a:solidFill>
                 <a:latin typeface="Consolas"/>
               </a:rPr>
-              <a:t>  .container </a:t>
+              <a:t>(max-width: 480px) </a:t>
             </a:r>
             <a:r>
               <a:rPr sz="800">
@@ -53141,11 +53257,11 @@
             <a:r>
               <a:rPr sz="800">
                 <a:solidFill>
-                  <a:srgbClr val="A78BFA"/>
-                </a:solidFill>
-                <a:latin typeface="Consolas"/>
-              </a:rPr>
-              <a:t>    width</a:t>
+                  <a:srgbClr val="F472B6"/>
+                </a:solidFill>
+                <a:latin typeface="Consolas"/>
+              </a:rPr>
+              <a:t>  .room-card </a:t>
             </a:r>
             <a:r>
               <a:rPr sz="800">
@@ -53154,16 +53270,29 @@
                 </a:solidFill>
                 <a:latin typeface="Consolas"/>
               </a:rPr>
-              <a:t>: </a:t>
-            </a:r>
-            <a:r>
-              <a:rPr sz="800">
-                <a:solidFill>
-                  <a:srgbClr val="4ADE80"/>
-                </a:solidFill>
-                <a:latin typeface="Consolas"/>
-              </a:rPr>
-              <a:t>100%</a:t>
+              <a:t>{ width: 100%; }</a:t>
+            </a:r>
+          </a:p>
+          <a:p>
+            <a:pPr>
+              <a:lnSpc>
+                <a:spcPct val="105000"/>
+              </a:lnSpc>
+              <a:spcBef>
+                <a:spcPts val="0"/>
+              </a:spcBef>
+              <a:spcAft>
+                <a:spcPts val="100"/>
+              </a:spcAft>
+            </a:pPr>
+            <a:r>
+              <a:rPr sz="800">
+                <a:solidFill>
+                  <a:srgbClr val="F472B6"/>
+                </a:solidFill>
+                <a:latin typeface="Consolas"/>
+              </a:rPr>
+              <a:t>  .header-container </a:t>
             </a:r>
             <a:r>
               <a:rPr sz="800">
@@ -53172,7 +53301,7 @@
                 </a:solidFill>
                 <a:latin typeface="Consolas"/>
               </a:rPr>
-              <a:t>;</a:t>
+              <a:t>{ flex-direction: column; gap: 12px; }</a:t>
             </a:r>
           </a:p>
           <a:p>
@@ -53190,11 +53319,11 @@
             <a:r>
               <a:rPr sz="800">
                 <a:solidFill>
-                  <a:srgbClr val="A78BFA"/>
-                </a:solidFill>
-                <a:latin typeface="Consolas"/>
-              </a:rPr>
-              <a:t>    padding</a:t>
+                  <a:srgbClr val="F472B6"/>
+                </a:solidFill>
+                <a:latin typeface="Consolas"/>
+              </a:rPr>
+              <a:t>  .btn </a:t>
             </a:r>
             <a:r>
               <a:rPr sz="800">
@@ -53203,388 +53332,7 @@
                 </a:solidFill>
                 <a:latin typeface="Consolas"/>
               </a:rPr>
-              <a:t>: </a:t>
-            </a:r>
-            <a:r>
-              <a:rPr sz="800">
-                <a:solidFill>
-                  <a:srgbClr val="4ADE80"/>
-                </a:solidFill>
-                <a:latin typeface="Consolas"/>
-              </a:rPr>
-              <a:t>0 16px</a:t>
-            </a:r>
-            <a:r>
-              <a:rPr sz="800">
-                <a:solidFill>
-                  <a:srgbClr val="D4D4D8"/>
-                </a:solidFill>
-                <a:latin typeface="Consolas"/>
-              </a:rPr>
-              <a:t>;</a:t>
-            </a:r>
-          </a:p>
-          <a:p>
-            <a:pPr>
-              <a:lnSpc>
-                <a:spcPct val="105000"/>
-              </a:lnSpc>
-              <a:spcBef>
-                <a:spcPts val="0"/>
-              </a:spcBef>
-              <a:spcAft>
-                <a:spcPts val="100"/>
-              </a:spcAft>
-            </a:pPr>
-            <a:r>
-              <a:rPr sz="800">
-                <a:solidFill>
-                  <a:srgbClr val="D4D4D8"/>
-                </a:solidFill>
-                <a:latin typeface="Consolas"/>
-              </a:rPr>
-              <a:t>  }</a:t>
-            </a:r>
-          </a:p>
-          <a:p>
-            <a:pPr>
-              <a:lnSpc>
-                <a:spcPct val="105000"/>
-              </a:lnSpc>
-              <a:spcBef>
-                <a:spcPts val="0"/>
-              </a:spcBef>
-              <a:spcAft>
-                <a:spcPts val="100"/>
-              </a:spcAft>
-            </a:pPr>
-            <a:r>
-              <a:rPr sz="800">
-                <a:solidFill>
-                  <a:srgbClr val="D4D4D8"/>
-                </a:solidFill>
-                <a:latin typeface="Consolas"/>
-              </a:rPr>
-              <a:t/>
-            </a:r>
-          </a:p>
-          <a:p>
-            <a:pPr>
-              <a:lnSpc>
-                <a:spcPct val="105000"/>
-              </a:lnSpc>
-              <a:spcBef>
-                <a:spcPts val="0"/>
-              </a:spcBef>
-              <a:spcAft>
-                <a:spcPts val="100"/>
-              </a:spcAft>
-            </a:pPr>
-            <a:r>
-              <a:rPr sz="800">
-                <a:solidFill>
-                  <a:srgbClr val="71717A"/>
-                </a:solidFill>
-                <a:latin typeface="Consolas"/>
-              </a:rPr>
-              <a:t>  /* 2. 2 колонки вместо 3 */</a:t>
-            </a:r>
-          </a:p>
-          <a:p>
-            <a:pPr>
-              <a:lnSpc>
-                <a:spcPct val="105000"/>
-              </a:lnSpc>
-              <a:spcBef>
-                <a:spcPts val="0"/>
-              </a:spcBef>
-              <a:spcAft>
-                <a:spcPts val="100"/>
-              </a:spcAft>
-            </a:pPr>
-            <a:r>
-              <a:rPr sz="800">
-                <a:solidFill>
-                  <a:srgbClr val="F472B6"/>
-                </a:solidFill>
-                <a:latin typeface="Consolas"/>
-              </a:rPr>
-              <a:t>  .room-card </a:t>
-            </a:r>
-            <a:r>
-              <a:rPr sz="800">
-                <a:solidFill>
-                  <a:srgbClr val="D4D4D8"/>
-                </a:solidFill>
-                <a:latin typeface="Consolas"/>
-              </a:rPr>
-              <a:t>{</a:t>
-            </a:r>
-          </a:p>
-          <a:p>
-            <a:pPr>
-              <a:lnSpc>
-                <a:spcPct val="105000"/>
-              </a:lnSpc>
-              <a:spcBef>
-                <a:spcPts val="0"/>
-              </a:spcBef>
-              <a:spcAft>
-                <a:spcPts val="100"/>
-              </a:spcAft>
-            </a:pPr>
-            <a:r>
-              <a:rPr sz="800">
-                <a:solidFill>
-                  <a:srgbClr val="A78BFA"/>
-                </a:solidFill>
-                <a:latin typeface="Consolas"/>
-              </a:rPr>
-              <a:t>    width</a:t>
-            </a:r>
-            <a:r>
-              <a:rPr sz="800">
-                <a:solidFill>
-                  <a:srgbClr val="D4D4D8"/>
-                </a:solidFill>
-                <a:latin typeface="Consolas"/>
-              </a:rPr>
-              <a:t>: </a:t>
-            </a:r>
-            <a:r>
-              <a:rPr sz="800">
-                <a:solidFill>
-                  <a:srgbClr val="4ADE80"/>
-                </a:solidFill>
-                <a:latin typeface="Consolas"/>
-              </a:rPr>
-              <a:t>calc(50% - 10px)</a:t>
-            </a:r>
-            <a:r>
-              <a:rPr sz="800">
-                <a:solidFill>
-                  <a:srgbClr val="D4D4D8"/>
-                </a:solidFill>
-                <a:latin typeface="Consolas"/>
-              </a:rPr>
-              <a:t>;</a:t>
-            </a:r>
-          </a:p>
-          <a:p>
-            <a:pPr>
-              <a:lnSpc>
-                <a:spcPct val="105000"/>
-              </a:lnSpc>
-              <a:spcBef>
-                <a:spcPts val="0"/>
-              </a:spcBef>
-              <a:spcAft>
-                <a:spcPts val="100"/>
-              </a:spcAft>
-            </a:pPr>
-            <a:r>
-              <a:rPr sz="800">
-                <a:solidFill>
-                  <a:srgbClr val="D4D4D8"/>
-                </a:solidFill>
-                <a:latin typeface="Consolas"/>
-              </a:rPr>
-              <a:t>  }</a:t>
-            </a:r>
-          </a:p>
-          <a:p>
-            <a:pPr>
-              <a:lnSpc>
-                <a:spcPct val="105000"/>
-              </a:lnSpc>
-              <a:spcBef>
-                <a:spcPts val="0"/>
-              </a:spcBef>
-              <a:spcAft>
-                <a:spcPts val="100"/>
-              </a:spcAft>
-            </a:pPr>
-            <a:r>
-              <a:rPr sz="800">
-                <a:solidFill>
-                  <a:srgbClr val="D4D4D8"/>
-                </a:solidFill>
-                <a:latin typeface="Consolas"/>
-              </a:rPr>
-              <a:t/>
-            </a:r>
-          </a:p>
-          <a:p>
-            <a:pPr>
-              <a:lnSpc>
-                <a:spcPct val="105000"/>
-              </a:lnSpc>
-              <a:spcBef>
-                <a:spcPts val="0"/>
-              </a:spcBef>
-              <a:spcAft>
-                <a:spcPts val="100"/>
-              </a:spcAft>
-            </a:pPr>
-            <a:r>
-              <a:rPr sz="800">
-                <a:solidFill>
-                  <a:srgbClr val="71717A"/>
-                </a:solidFill>
-                <a:latin typeface="Consolas"/>
-              </a:rPr>
-              <a:t>  /* 3. Оптимизация заголовка Hero */</a:t>
-            </a:r>
-          </a:p>
-          <a:p>
-            <a:pPr>
-              <a:lnSpc>
-                <a:spcPct val="105000"/>
-              </a:lnSpc>
-              <a:spcBef>
-                <a:spcPts val="0"/>
-              </a:spcBef>
-              <a:spcAft>
-                <a:spcPts val="100"/>
-              </a:spcAft>
-            </a:pPr>
-            <a:r>
-              <a:rPr sz="800">
-                <a:solidFill>
-                  <a:srgbClr val="F472B6"/>
-                </a:solidFill>
-                <a:latin typeface="Consolas"/>
-              </a:rPr>
-              <a:t>  .hero-title </a:t>
-            </a:r>
-            <a:r>
-              <a:rPr sz="800">
-                <a:solidFill>
-                  <a:srgbClr val="D4D4D8"/>
-                </a:solidFill>
-                <a:latin typeface="Consolas"/>
-              </a:rPr>
-              <a:t>{</a:t>
-            </a:r>
-          </a:p>
-          <a:p>
-            <a:pPr>
-              <a:lnSpc>
-                <a:spcPct val="105000"/>
-              </a:lnSpc>
-              <a:spcBef>
-                <a:spcPts val="0"/>
-              </a:spcBef>
-              <a:spcAft>
-                <a:spcPts val="100"/>
-              </a:spcAft>
-            </a:pPr>
-            <a:r>
-              <a:rPr sz="800">
-                <a:solidFill>
-                  <a:srgbClr val="A78BFA"/>
-                </a:solidFill>
-                <a:latin typeface="Consolas"/>
-              </a:rPr>
-              <a:t>    font-size</a:t>
-            </a:r>
-            <a:r>
-              <a:rPr sz="800">
-                <a:solidFill>
-                  <a:srgbClr val="D4D4D8"/>
-                </a:solidFill>
-                <a:latin typeface="Consolas"/>
-              </a:rPr>
-              <a:t>: </a:t>
-            </a:r>
-            <a:r>
-              <a:rPr sz="800">
-                <a:solidFill>
-                  <a:srgbClr val="4ADE80"/>
-                </a:solidFill>
-                <a:latin typeface="Consolas"/>
-              </a:rPr>
-              <a:t>52px</a:t>
-            </a:r>
-            <a:r>
-              <a:rPr sz="800">
-                <a:solidFill>
-                  <a:srgbClr val="D4D4D8"/>
-                </a:solidFill>
-                <a:latin typeface="Consolas"/>
-              </a:rPr>
-              <a:t>;</a:t>
-            </a:r>
-          </a:p>
-          <a:p>
-            <a:pPr>
-              <a:lnSpc>
-                <a:spcPct val="105000"/>
-              </a:lnSpc>
-              <a:spcBef>
-                <a:spcPts val="0"/>
-              </a:spcBef>
-              <a:spcAft>
-                <a:spcPts val="100"/>
-              </a:spcAft>
-            </a:pPr>
-            <a:r>
-              <a:rPr sz="800">
-                <a:solidFill>
-                  <a:srgbClr val="A78BFA"/>
-                </a:solidFill>
-                <a:latin typeface="Consolas"/>
-              </a:rPr>
-              <a:t>    line-height</a:t>
-            </a:r>
-            <a:r>
-              <a:rPr sz="800">
-                <a:solidFill>
-                  <a:srgbClr val="D4D4D8"/>
-                </a:solidFill>
-                <a:latin typeface="Consolas"/>
-              </a:rPr>
-              <a:t>: </a:t>
-            </a:r>
-            <a:r>
-              <a:rPr sz="800">
-                <a:solidFill>
-                  <a:srgbClr val="4ADE80"/>
-                </a:solidFill>
-                <a:latin typeface="Consolas"/>
-              </a:rPr>
-              <a:t>1.1</a:t>
-            </a:r>
-            <a:r>
-              <a:rPr sz="800">
-                <a:solidFill>
-                  <a:srgbClr val="D4D4D8"/>
-                </a:solidFill>
-                <a:latin typeface="Consolas"/>
-              </a:rPr>
-              <a:t>;</a:t>
-            </a:r>
-          </a:p>
-          <a:p>
-            <a:pPr>
-              <a:lnSpc>
-                <a:spcPct val="105000"/>
-              </a:lnSpc>
-              <a:spcBef>
-                <a:spcPts val="0"/>
-              </a:spcBef>
-              <a:spcAft>
-                <a:spcPts val="100"/>
-              </a:spcAft>
-            </a:pPr>
-            <a:r>
-              <a:rPr sz="800">
-                <a:solidFill>
-                  <a:srgbClr val="D4D4D8"/>
-                </a:solidFill>
-                <a:latin typeface="Consolas"/>
-              </a:rPr>
-              <a:t>  }</a:t>
+              <a:t>{ padding: 12px 20px; font-size: 15px; }</a:t>
             </a:r>
           </a:p>
           <a:p>
@@ -53619,8 +53367,8 @@
         </p:nvSpPr>
         <p:spPr>
           <a:xfrm>
-            <a:off x="4749800" y="685800"/>
-            <a:ext cx="4089400" cy="355600"/>
+            <a:off x="4749800" y="762000"/>
+            <a:ext cx="4089400" cy="228600"/>
           </a:xfrm>
           <a:prstGeom prst="rect">
             <a:avLst/>
@@ -53639,13 +53387,13 @@
               </a:lnSpc>
             </a:pPr>
             <a:r>
-              <a:rPr sz="1000" b="1">
+              <a:rPr sz="1050" b="1">
                 <a:solidFill>
                   <a:srgbClr val="FF6F03"/>
                 </a:solidFill>
                 <a:latin typeface="Montserrat"/>
               </a:rPr>
-              <a:t>ТАКТИКА АДАПТАЦИИ ДЛЯ СРЕДНИХ ЭКРАНОВ</a:t>
+              <a:t>ТАКТИКА АДАПТАЦИИ ПОД ВСЕ ЭКРАНЫ</a:t>
             </a:r>
           </a:p>
         </p:txBody>
@@ -53658,7 +53406,7 @@
         </p:nvSpPr>
         <p:spPr>
           <a:xfrm>
-            <a:off x="4749800" y="1079500"/>
+            <a:off x="4749800" y="1041400"/>
             <a:ext cx="4089400" cy="12700"/>
           </a:xfrm>
           <a:prstGeom prst="rect">
@@ -53687,7 +53435,7 @@
         </p:nvSpPr>
         <p:spPr>
           <a:xfrm>
-            <a:off x="4749800" y="1238250"/>
+            <a:off x="4749800" y="1200150"/>
             <a:ext cx="82550" cy="82550"/>
           </a:xfrm>
           <a:prstGeom prst="roundRect">
@@ -53718,7 +53466,7 @@
         </p:nvSpPr>
         <p:spPr>
           <a:xfrm>
-            <a:off x="4940300" y="1193800"/>
+            <a:off x="4940300" y="1155700"/>
             <a:ext cx="3898900" cy="609600"/>
           </a:xfrm>
           <a:prstGeom prst="rect">
@@ -53763,7 +53511,7 @@
                 </a:solidFill>
                 <a:latin typeface="Inter"/>
               </a:rPr>
-              <a:t>На экране шириной 768px фиксированный контейнер 1200px вызовет горизонтальный скролл. width: 100% делает верстку резиновой.</a:t>
+              <a:t>Свойство width: 100% устраняет фиксированную ширину и защищает мобильные экраны от появления горизонтального скролла.</a:t>
             </a:r>
           </a:p>
         </p:txBody>
@@ -53776,7 +53524,7 @@
         </p:nvSpPr>
         <p:spPr>
           <a:xfrm>
-            <a:off x="4749800" y="2025650"/>
+            <a:off x="4749800" y="2012950"/>
             <a:ext cx="82550" cy="82550"/>
           </a:xfrm>
           <a:prstGeom prst="roundRect">
@@ -53807,7 +53555,7 @@
         </p:nvSpPr>
         <p:spPr>
           <a:xfrm>
-            <a:off x="4940300" y="1981200"/>
+            <a:off x="4940300" y="1968500"/>
             <a:ext cx="3898900" cy="609600"/>
           </a:xfrm>
           <a:prstGeom prst="rect">
@@ -53833,7 +53581,7 @@
                 </a:solidFill>
                 <a:latin typeface="Montserrat"/>
               </a:rPr>
-              <a:t>Формула calc(50% - 10px):</a:t>
+              <a:t>Сетка колонок (2 -&gt; 1):</a:t>
             </a:r>
           </a:p>
           <a:p>
@@ -53852,7 +53600,7 @@
                 </a:solidFill>
                 <a:latin typeface="Inter"/>
               </a:rPr>
-              <a:t>При промежутке gap: 20px между двумя колонками каждая карточка занимает ровно половину ширины за вычетом половины зазора.</a:t>
+              <a:t>На планшетах карточки выстраиваются по две в ряд через calc(50% - 10px), а на смартфонах разворачиваются в 100% ленту.</a:t>
             </a:r>
           </a:p>
         </p:txBody>
@@ -53865,7 +53613,7 @@
         </p:nvSpPr>
         <p:spPr>
           <a:xfrm>
-            <a:off x="4749800" y="2813050"/>
+            <a:off x="4749800" y="2825750"/>
             <a:ext cx="82550" cy="82550"/>
           </a:xfrm>
           <a:prstGeom prst="roundRect">
@@ -53896,7 +53644,7 @@
         </p:nvSpPr>
         <p:spPr>
           <a:xfrm>
-            <a:off x="4940300" y="2768600"/>
+            <a:off x="4940300" y="2781300"/>
             <a:ext cx="3898900" cy="609600"/>
           </a:xfrm>
           <a:prstGeom prst="rect">
@@ -53922,7 +53670,7 @@
                 </a:solidFill>
                 <a:latin typeface="Montserrat"/>
               </a:rPr>
-              <a:t>Боковые поля безопасности:</a:t>
+              <a:t>Вертикальный стек в шапке:</a:t>
             </a:r>
           </a:p>
           <a:p>
@@ -53941,7 +53689,7 @@
                 </a:solidFill>
                 <a:latin typeface="Inter"/>
               </a:rPr>
-              <a:t>padding: 0 16px предотвращает некрасивое прилипание карточек и текста к физическим стеклянным рамкам планшета.</a:t>
+              <a:t>Директива flex-direction: column гармонично размещает логотип и ссылки навигации друг под другом на узких дисплеях.</a:t>
             </a:r>
           </a:p>
         </p:txBody>
@@ -53954,7 +53702,7 @@
         </p:nvSpPr>
         <p:spPr>
           <a:xfrm>
-            <a:off x="4749800" y="3600450"/>
+            <a:off x="4749800" y="3638550"/>
             <a:ext cx="82550" cy="82550"/>
           </a:xfrm>
           <a:prstGeom prst="roundRect">
@@ -53985,7 +53733,7 @@
         </p:nvSpPr>
         <p:spPr>
           <a:xfrm>
-            <a:off x="4940300" y="3556000"/>
+            <a:off x="4940300" y="3594100"/>
             <a:ext cx="3898900" cy="609600"/>
           </a:xfrm>
           <a:prstGeom prst="rect">
@@ -54011,7 +53759,7 @@
                 </a:solidFill>
                 <a:latin typeface="Montserrat"/>
               </a:rPr>
-              <a:t>Сжатие hero-типографики:</a:t>
+              <a:t>Увеличение тач-зон (Touch Targets):</a:t>
             </a:r>
           </a:p>
           <a:p>
@@ -54030,7 +53778,7 @@
                 </a:solidFill>
                 <a:latin typeface="Inter"/>
               </a:rPr>
-              <a:t>Огромный шрифт 108px на планшете не поместится в одну строку, поэтому кегль уменьшается до гармоничных 52px.</a:t>
+              <a:t>Кнопки и ссылки получают увеличенные отступы (padding), делая интерфейс удобным для быстрого нажатия пальцем.</a:t>
             </a:r>
           </a:p>
         </p:txBody>
@@ -54061,8 +53809,8 @@
         </p:nvSpPr>
         <p:spPr>
           <a:xfrm>
-            <a:off x="6316980" y="259079"/>
-            <a:ext cx="2573020" cy="287020"/>
+            <a:off x="6192520" y="259079"/>
+            <a:ext cx="2697480" cy="287020"/>
           </a:xfrm>
           <a:prstGeom prst="roundRect">
             <a:avLst>
@@ -54090,7 +53838,7 @@
                 </a:solidFill>
                 <a:latin typeface="Inter"/>
               </a:rPr>
-              <a:t>МОБИЛЬНАЯ ВЕРСТКА</a:t>
+              <a:t>ПЕРЕИСПОЛЬЗУЕМОСТЬ</a:t>
             </a:r>
           </a:p>
         </p:txBody>
@@ -54125,7 +53873,7 @@
                 </a:solidFill>
                 <a:latin typeface="Montserrat"/>
               </a:rPr>
-              <a:t>Как трансформировать карточки в удобную вертикальную ленту для пальца?</a:t>
+              <a:t>Как мгновенно изменить цветовую тему проекта заменой одной строчки в :root?</a:t>
             </a:r>
           </a:p>
         </p:txBody>
@@ -54192,7 +53940,7 @@
                 </a:solidFill>
                 <a:latin typeface="Consolas"/>
               </a:rPr>
-              <a:t>📄 css/style.css (@media max-width: 480px)</a:t>
+              <a:t>📄 css/style.css (Динамические темы)</a:t>
             </a:r>
           </a:p>
         </p:txBody>
@@ -54262,12 +54010,25 @@
             <a:r>
               <a:rPr sz="800">
                 <a:solidFill>
-                  <a:srgbClr val="38BDF8"/>
-                </a:solidFill>
-                <a:latin typeface="Consolas"/>
-              </a:rPr>
-              <a:t>@media </a:t>
-            </a:r>
+                  <a:srgbClr val="71717A"/>
+                </a:solidFill>
+                <a:latin typeface="Consolas"/>
+              </a:rPr>
+              <a:t>/* Базовая тема (СмартОфис) */</a:t>
+            </a:r>
+          </a:p>
+          <a:p>
+            <a:pPr>
+              <a:lnSpc>
+                <a:spcPct val="105000"/>
+              </a:lnSpc>
+              <a:spcBef>
+                <a:spcPts val="0"/>
+              </a:spcBef>
+              <a:spcAft>
+                <a:spcPts val="100"/>
+              </a:spcAft>
+            </a:pPr>
             <a:r>
               <a:rPr sz="800">
                 <a:solidFill>
@@ -54275,7 +54036,7 @@
                 </a:solidFill>
                 <a:latin typeface="Consolas"/>
               </a:rPr>
-              <a:t>(max-width: 480px) </a:t>
+              <a:t>:root </a:t>
             </a:r>
             <a:r>
               <a:rPr sz="800">
@@ -54302,11 +54063,153 @@
             <a:r>
               <a:rPr sz="800">
                 <a:solidFill>
+                  <a:srgbClr val="A78BFA"/>
+                </a:solidFill>
+                <a:latin typeface="Consolas"/>
+              </a:rPr>
+              <a:t>  --primary-color</a:t>
+            </a:r>
+            <a:r>
+              <a:rPr sz="800">
+                <a:solidFill>
+                  <a:srgbClr val="D4D4D8"/>
+                </a:solidFill>
+                <a:latin typeface="Consolas"/>
+              </a:rPr>
+              <a:t>: </a:t>
+            </a:r>
+            <a:r>
+              <a:rPr sz="800">
+                <a:solidFill>
+                  <a:srgbClr val="4ADE80"/>
+                </a:solidFill>
+                <a:latin typeface="Consolas"/>
+              </a:rPr>
+              <a:t>#007bff</a:t>
+            </a:r>
+            <a:r>
+              <a:rPr sz="800">
+                <a:solidFill>
+                  <a:srgbClr val="D4D4D8"/>
+                </a:solidFill>
+                <a:latin typeface="Consolas"/>
+              </a:rPr>
+              <a:t>;</a:t>
+            </a:r>
+          </a:p>
+          <a:p>
+            <a:pPr>
+              <a:lnSpc>
+                <a:spcPct val="105000"/>
+              </a:lnSpc>
+              <a:spcBef>
+                <a:spcPts val="0"/>
+              </a:spcBef>
+              <a:spcAft>
+                <a:spcPts val="100"/>
+              </a:spcAft>
+            </a:pPr>
+            <a:r>
+              <a:rPr sz="800">
+                <a:solidFill>
+                  <a:srgbClr val="A78BFA"/>
+                </a:solidFill>
+                <a:latin typeface="Consolas"/>
+              </a:rPr>
+              <a:t>  --primary-hover</a:t>
+            </a:r>
+            <a:r>
+              <a:rPr sz="800">
+                <a:solidFill>
+                  <a:srgbClr val="D4D4D8"/>
+                </a:solidFill>
+                <a:latin typeface="Consolas"/>
+              </a:rPr>
+              <a:t>: </a:t>
+            </a:r>
+            <a:r>
+              <a:rPr sz="800">
+                <a:solidFill>
+                  <a:srgbClr val="4ADE80"/>
+                </a:solidFill>
+                <a:latin typeface="Consolas"/>
+              </a:rPr>
+              <a:t>#0056b3</a:t>
+            </a:r>
+            <a:r>
+              <a:rPr sz="800">
+                <a:solidFill>
+                  <a:srgbClr val="D4D4D8"/>
+                </a:solidFill>
+                <a:latin typeface="Consolas"/>
+              </a:rPr>
+              <a:t>;</a:t>
+            </a:r>
+          </a:p>
+          <a:p>
+            <a:pPr>
+              <a:lnSpc>
+                <a:spcPct val="105000"/>
+              </a:lnSpc>
+              <a:spcBef>
+                <a:spcPts val="0"/>
+              </a:spcBef>
+              <a:spcAft>
+                <a:spcPts val="100"/>
+              </a:spcAft>
+            </a:pPr>
+            <a:r>
+              <a:rPr sz="800">
+                <a:solidFill>
+                  <a:srgbClr val="D4D4D8"/>
+                </a:solidFill>
+                <a:latin typeface="Consolas"/>
+              </a:rPr>
+              <a:t>}</a:t>
+            </a:r>
+          </a:p>
+          <a:p>
+            <a:pPr>
+              <a:lnSpc>
+                <a:spcPct val="105000"/>
+              </a:lnSpc>
+              <a:spcBef>
+                <a:spcPts val="0"/>
+              </a:spcBef>
+              <a:spcAft>
+                <a:spcPts val="100"/>
+              </a:spcAft>
+            </a:pPr>
+            <a:r>
+              <a:rPr sz="800">
+                <a:solidFill>
+                  <a:srgbClr val="D4D4D8"/>
+                </a:solidFill>
+                <a:latin typeface="Consolas"/>
+              </a:rPr>
+              <a:t/>
+            </a:r>
+          </a:p>
+          <a:p>
+            <a:pPr>
+              <a:lnSpc>
+                <a:spcPct val="105000"/>
+              </a:lnSpc>
+              <a:spcBef>
+                <a:spcPts val="0"/>
+              </a:spcBef>
+              <a:spcAft>
+                <a:spcPts val="100"/>
+              </a:spcAft>
+            </a:pPr>
+            <a:r>
+              <a:rPr sz="800">
+                <a:solidFill>
                   <a:srgbClr val="71717A"/>
                 </a:solidFill>
                 <a:latin typeface="Consolas"/>
               </a:rPr>
-              <a:t>  /* Карточка на всю ширину */</a:t>
+              <a:t>/* Тема 'Изумрудный Коворкинг' */</a:t>
             </a:r>
           </a:p>
           <a:p>
@@ -54328,7 +54231,7 @@
                 </a:solidFill>
                 <a:latin typeface="Consolas"/>
               </a:rPr>
-              <a:t>  .room-card </a:t>
+              <a:t>body.theme-emerald </a:t>
             </a:r>
             <a:r>
               <a:rPr sz="800">
@@ -54359,7 +54262,7 @@
                 </a:solidFill>
                 <a:latin typeface="Consolas"/>
               </a:rPr>
-              <a:t>    width</a:t>
+              <a:t>  --primary-color</a:t>
             </a:r>
             <a:r>
               <a:rPr sz="800">
@@ -54377,7 +54280,7 @@
                 </a:solidFill>
                 <a:latin typeface="Consolas"/>
               </a:rPr>
-              <a:t>100%</a:t>
+              <a:t>#10b981</a:t>
             </a:r>
             <a:r>
               <a:rPr sz="800">
@@ -54404,11 +54307,38 @@
             <a:r>
               <a:rPr sz="800">
                 <a:solidFill>
+                  <a:srgbClr val="A78BFA"/>
+                </a:solidFill>
+                <a:latin typeface="Consolas"/>
+              </a:rPr>
+              <a:t>  --primary-hover</a:t>
+            </a:r>
+            <a:r>
+              <a:rPr sz="800">
+                <a:solidFill>
                   <a:srgbClr val="D4D4D8"/>
                 </a:solidFill>
                 <a:latin typeface="Consolas"/>
               </a:rPr>
-              <a:t>  }</a:t>
+              <a:t>: </a:t>
+            </a:r>
+            <a:r>
+              <a:rPr sz="800">
+                <a:solidFill>
+                  <a:srgbClr val="4ADE80"/>
+                </a:solidFill>
+                <a:latin typeface="Consolas"/>
+              </a:rPr>
+              <a:t>#059669</a:t>
+            </a:r>
+            <a:r>
+              <a:rPr sz="800">
+                <a:solidFill>
+                  <a:srgbClr val="D4D4D8"/>
+                </a:solidFill>
+                <a:latin typeface="Consolas"/>
+              </a:rPr>
+              <a:t>;</a:t>
             </a:r>
           </a:p>
           <a:p>
@@ -54430,6 +54360,28 @@
                 </a:solidFill>
                 <a:latin typeface="Consolas"/>
               </a:rPr>
+              <a:t>}</a:t>
+            </a:r>
+          </a:p>
+          <a:p>
+            <a:pPr>
+              <a:lnSpc>
+                <a:spcPct val="105000"/>
+              </a:lnSpc>
+              <a:spcBef>
+                <a:spcPts val="0"/>
+              </a:spcBef>
+              <a:spcAft>
+                <a:spcPts val="100"/>
+              </a:spcAft>
+            </a:pPr>
+            <a:r>
+              <a:rPr sz="800">
+                <a:solidFill>
+                  <a:srgbClr val="D4D4D8"/>
+                </a:solidFill>
+                <a:latin typeface="Consolas"/>
+              </a:rPr>
               <a:t/>
             </a:r>
           </a:p>
@@ -54452,7 +54404,7 @@
                 </a:solidFill>
                 <a:latin typeface="Consolas"/>
               </a:rPr>
-              <a:t>  /* Стек шапки сайта */</a:t>
+              <a:t>/* Тема 'Премиум Фиолетовый' */</a:t>
             </a:r>
           </a:p>
           <a:p>
@@ -54474,7 +54426,7 @@
                 </a:solidFill>
                 <a:latin typeface="Consolas"/>
               </a:rPr>
-              <a:t>  .header-container </a:t>
+              <a:t>body.theme-purple </a:t>
             </a:r>
             <a:r>
               <a:rPr sz="800">
@@ -54505,7 +54457,7 @@
                 </a:solidFill>
                 <a:latin typeface="Consolas"/>
               </a:rPr>
-              <a:t>    flex-direction</a:t>
+              <a:t>  --primary-color</a:t>
             </a:r>
             <a:r>
               <a:rPr sz="800">
@@ -54523,7 +54475,7 @@
                 </a:solidFill>
                 <a:latin typeface="Consolas"/>
               </a:rPr>
-              <a:t>column</a:t>
+              <a:t>#8b5cf6</a:t>
             </a:r>
             <a:r>
               <a:rPr sz="800">
@@ -54554,7 +54506,7 @@
                 </a:solidFill>
                 <a:latin typeface="Consolas"/>
               </a:rPr>
-              <a:t>    gap</a:t>
+              <a:t>  --primary-hover</a:t>
             </a:r>
             <a:r>
               <a:rPr sz="800">
@@ -54572,7 +54524,7 @@
                 </a:solidFill>
                 <a:latin typeface="Consolas"/>
               </a:rPr>
-              <a:t>12px</a:t>
+              <a:t>#7c3aed</a:t>
             </a:r>
             <a:r>
               <a:rPr sz="800">
@@ -54582,223 +54534,6 @@
                 <a:latin typeface="Consolas"/>
               </a:rPr>
               <a:t>;</a:t>
-            </a:r>
-          </a:p>
-          <a:p>
-            <a:pPr>
-              <a:lnSpc>
-                <a:spcPct val="105000"/>
-              </a:lnSpc>
-              <a:spcBef>
-                <a:spcPts val="0"/>
-              </a:spcBef>
-              <a:spcAft>
-                <a:spcPts val="100"/>
-              </a:spcAft>
-            </a:pPr>
-            <a:r>
-              <a:rPr sz="800">
-                <a:solidFill>
-                  <a:srgbClr val="D4D4D8"/>
-                </a:solidFill>
-                <a:latin typeface="Consolas"/>
-              </a:rPr>
-              <a:t>  }</a:t>
-            </a:r>
-          </a:p>
-          <a:p>
-            <a:pPr>
-              <a:lnSpc>
-                <a:spcPct val="105000"/>
-              </a:lnSpc>
-              <a:spcBef>
-                <a:spcPts val="0"/>
-              </a:spcBef>
-              <a:spcAft>
-                <a:spcPts val="100"/>
-              </a:spcAft>
-            </a:pPr>
-            <a:r>
-              <a:rPr sz="800">
-                <a:solidFill>
-                  <a:srgbClr val="D4D4D8"/>
-                </a:solidFill>
-                <a:latin typeface="Consolas"/>
-              </a:rPr>
-              <a:t/>
-            </a:r>
-          </a:p>
-          <a:p>
-            <a:pPr>
-              <a:lnSpc>
-                <a:spcPct val="105000"/>
-              </a:lnSpc>
-              <a:spcBef>
-                <a:spcPts val="0"/>
-              </a:spcBef>
-              <a:spcAft>
-                <a:spcPts val="100"/>
-              </a:spcAft>
-            </a:pPr>
-            <a:r>
-              <a:rPr sz="800">
-                <a:solidFill>
-                  <a:srgbClr val="71717A"/>
-                </a:solidFill>
-                <a:latin typeface="Consolas"/>
-              </a:rPr>
-              <a:t>  /* Увеличение кнопок под тач */</a:t>
-            </a:r>
-          </a:p>
-          <a:p>
-            <a:pPr>
-              <a:lnSpc>
-                <a:spcPct val="105000"/>
-              </a:lnSpc>
-              <a:spcBef>
-                <a:spcPts val="0"/>
-              </a:spcBef>
-              <a:spcAft>
-                <a:spcPts val="100"/>
-              </a:spcAft>
-            </a:pPr>
-            <a:r>
-              <a:rPr sz="800">
-                <a:solidFill>
-                  <a:srgbClr val="F472B6"/>
-                </a:solidFill>
-                <a:latin typeface="Consolas"/>
-              </a:rPr>
-              <a:t>  .btn </a:t>
-            </a:r>
-            <a:r>
-              <a:rPr sz="800">
-                <a:solidFill>
-                  <a:srgbClr val="D4D4D8"/>
-                </a:solidFill>
-                <a:latin typeface="Consolas"/>
-              </a:rPr>
-              <a:t>{</a:t>
-            </a:r>
-          </a:p>
-          <a:p>
-            <a:pPr>
-              <a:lnSpc>
-                <a:spcPct val="105000"/>
-              </a:lnSpc>
-              <a:spcBef>
-                <a:spcPts val="0"/>
-              </a:spcBef>
-              <a:spcAft>
-                <a:spcPts val="100"/>
-              </a:spcAft>
-            </a:pPr>
-            <a:r>
-              <a:rPr sz="800">
-                <a:solidFill>
-                  <a:srgbClr val="A78BFA"/>
-                </a:solidFill>
-                <a:latin typeface="Consolas"/>
-              </a:rPr>
-              <a:t>    padding</a:t>
-            </a:r>
-            <a:r>
-              <a:rPr sz="800">
-                <a:solidFill>
-                  <a:srgbClr val="D4D4D8"/>
-                </a:solidFill>
-                <a:latin typeface="Consolas"/>
-              </a:rPr>
-              <a:t>: </a:t>
-            </a:r>
-            <a:r>
-              <a:rPr sz="800">
-                <a:solidFill>
-                  <a:srgbClr val="4ADE80"/>
-                </a:solidFill>
-                <a:latin typeface="Consolas"/>
-              </a:rPr>
-              <a:t>10px 18px</a:t>
-            </a:r>
-            <a:r>
-              <a:rPr sz="800">
-                <a:solidFill>
-                  <a:srgbClr val="D4D4D8"/>
-                </a:solidFill>
-                <a:latin typeface="Consolas"/>
-              </a:rPr>
-              <a:t>;</a:t>
-            </a:r>
-          </a:p>
-          <a:p>
-            <a:pPr>
-              <a:lnSpc>
-                <a:spcPct val="105000"/>
-              </a:lnSpc>
-              <a:spcBef>
-                <a:spcPts val="0"/>
-              </a:spcBef>
-              <a:spcAft>
-                <a:spcPts val="100"/>
-              </a:spcAft>
-            </a:pPr>
-            <a:r>
-              <a:rPr sz="800">
-                <a:solidFill>
-                  <a:srgbClr val="A78BFA"/>
-                </a:solidFill>
-                <a:latin typeface="Consolas"/>
-              </a:rPr>
-              <a:t>    font-size</a:t>
-            </a:r>
-            <a:r>
-              <a:rPr sz="800">
-                <a:solidFill>
-                  <a:srgbClr val="D4D4D8"/>
-                </a:solidFill>
-                <a:latin typeface="Consolas"/>
-              </a:rPr>
-              <a:t>: </a:t>
-            </a:r>
-            <a:r>
-              <a:rPr sz="800">
-                <a:solidFill>
-                  <a:srgbClr val="4ADE80"/>
-                </a:solidFill>
-                <a:latin typeface="Consolas"/>
-              </a:rPr>
-              <a:t>15px</a:t>
-            </a:r>
-            <a:r>
-              <a:rPr sz="800">
-                <a:solidFill>
-                  <a:srgbClr val="D4D4D8"/>
-                </a:solidFill>
-                <a:latin typeface="Consolas"/>
-              </a:rPr>
-              <a:t>;</a:t>
-            </a:r>
-          </a:p>
-          <a:p>
-            <a:pPr>
-              <a:lnSpc>
-                <a:spcPct val="105000"/>
-              </a:lnSpc>
-              <a:spcBef>
-                <a:spcPts val="0"/>
-              </a:spcBef>
-              <a:spcAft>
-                <a:spcPts val="100"/>
-              </a:spcAft>
-            </a:pPr>
-            <a:r>
-              <a:rPr sz="800">
-                <a:solidFill>
-                  <a:srgbClr val="D4D4D8"/>
-                </a:solidFill>
-                <a:latin typeface="Consolas"/>
-              </a:rPr>
-              <a:t>  }</a:t>
             </a:r>
           </a:p>
           <a:p>
@@ -54859,7 +54594,7 @@
                 </a:solidFill>
                 <a:latin typeface="Montserrat"/>
               </a:rPr>
-              <a:t>ПРАВИЛА УДОБСТВА НА ЭКРАНАХ СМАРТФОНОВ</a:t>
+              <a:t>КАСКАД ПЕРЕМЕННЫХ И WHITE-LABEL АРХИТЕКТУРА</a:t>
             </a:r>
           </a:p>
         </p:txBody>
@@ -54958,7 +54693,7 @@
                 </a:solidFill>
                 <a:latin typeface="Montserrat"/>
               </a:rPr>
-              <a:t>Ширина 100% (Одноколоночный поток):</a:t>
+              <a:t>Локальное переопределение токенов:</a:t>
             </a:r>
           </a:p>
           <a:p>
@@ -54977,7 +54712,7 @@
                 </a:solidFill>
                 <a:latin typeface="Inter"/>
               </a:rPr>
-              <a:t>На экране смартфона 360-400px две колонки карточек выглядели бы мелко. 100% ширины превращает витрину в комфортную ленту.</a:t>
+              <a:t>Селектор body.theme-emerald переопределяет переменные для себя и всех дочерних элементов благодаря каскаду CSS.</a:t>
             </a:r>
           </a:p>
         </p:txBody>
@@ -54990,7 +54725,7 @@
         </p:nvSpPr>
         <p:spPr>
           <a:xfrm>
-            <a:off x="4749800" y="2025650"/>
+            <a:off x="4749800" y="2051050"/>
             <a:ext cx="82550" cy="82550"/>
           </a:xfrm>
           <a:prstGeom prst="roundRect">
@@ -55021,7 +54756,7 @@
         </p:nvSpPr>
         <p:spPr>
           <a:xfrm>
-            <a:off x="4940300" y="1981200"/>
+            <a:off x="4940300" y="2006600"/>
             <a:ext cx="3898900" cy="609600"/>
           </a:xfrm>
           <a:prstGeom prst="rect">
@@ -55047,7 +54782,7 @@
                 </a:solidFill>
                 <a:latin typeface="Montserrat"/>
               </a:rPr>
-              <a:t>Увеличение тач-зон (Touch Targets):</a:t>
+              <a:t>0% переписывания стилей компонентов:</a:t>
             </a:r>
           </a:p>
           <a:p>
@@ -55066,7 +54801,7 @@
                 </a:solidFill>
                 <a:latin typeface="Inter"/>
               </a:rPr>
-              <a:t>Палец человека больше курсора мыши. Высота кнопок увеличивается (минимум 44px) для безошибочного нажатия в движении.</a:t>
+              <a:t>Кнопки, иконки, ссылки и фокусные рамки карточек читают var(--primary-color) и преображаются автоматически без единой правки.</a:t>
             </a:r>
           </a:p>
         </p:txBody>
@@ -55079,7 +54814,7 @@
         </p:nvSpPr>
         <p:spPr>
           <a:xfrm>
-            <a:off x="4749800" y="2813050"/>
+            <a:off x="4749800" y="2863850"/>
             <a:ext cx="82550" cy="82550"/>
           </a:xfrm>
           <a:prstGeom prst="roundRect">
@@ -55110,7 +54845,7 @@
         </p:nvSpPr>
         <p:spPr>
           <a:xfrm>
-            <a:off x="4940300" y="2768600"/>
+            <a:off x="4940300" y="2819400"/>
             <a:ext cx="3898900" cy="609600"/>
           </a:xfrm>
           <a:prstGeom prst="rect">
@@ -55136,7 +54871,7 @@
                 </a:solidFill>
                 <a:latin typeface="Montserrat"/>
               </a:rPr>
-              <a:t>Вертикальная шапка (column):</a:t>
+              <a:t>Основа White-label разработки:</a:t>
             </a:r>
           </a:p>
           <a:p>
@@ -55155,7 +54890,7 @@
                 </a:solidFill>
                 <a:latin typeface="Inter"/>
               </a:rPr>
-              <a:t>Логотип и ссылки меню на узком экране не помещаются в ряд и аккуратно выстраиваются друг под другом по центру.</a:t>
+              <a:t>Один и тот же движок бронирования офисов можно продавать разным заказчикам, меняя лишь файл переменных брендовой гаммы.</a:t>
             </a:r>
           </a:p>
         </p:txBody>
@@ -55168,7 +54903,7 @@
         </p:nvSpPr>
         <p:spPr>
           <a:xfrm>
-            <a:off x="4749800" y="3600450"/>
+            <a:off x="4749800" y="3676650"/>
             <a:ext cx="82550" cy="82550"/>
           </a:xfrm>
           <a:prstGeom prst="roundRect">
@@ -55199,7 +54934,7 @@
         </p:nvSpPr>
         <p:spPr>
           <a:xfrm>
-            <a:off x="4940300" y="3556000"/>
+            <a:off x="4940300" y="3632200"/>
             <a:ext cx="3898900" cy="609600"/>
           </a:xfrm>
           <a:prstGeom prst="rect">
@@ -55225,7 +54960,7 @@
                 </a:solidFill>
                 <a:latin typeface="Montserrat"/>
               </a:rPr>
-              <a:t>Защита от горизонтальной прокрутки:</a:t>
+              <a:t>Переключение в 1 строчку через JS:</a:t>
             </a:r>
           </a:p>
           <a:p>
@@ -55244,7 +54979,7 @@
                 </a:solidFill>
                 <a:latin typeface="Inter"/>
               </a:rPr>
-              <a:t>Каждый блок проверяется на отсутствие фиксированных пиксельных ширин, исключая 'болтанку' страницы влево-вправо.</a:t>
+              <a:t>В JavaScript достаточно выполнить document.body.className = 'theme-emerald', чтобы весь интерфейс сменил стиль прямо на лету!</a:t>
             </a:r>
           </a:p>
         </p:txBody>
@@ -55275,8 +55010,8 @@
         </p:nvSpPr>
         <p:spPr>
           <a:xfrm>
-            <a:off x="6192520" y="259079"/>
-            <a:ext cx="2697480" cy="287020"/>
+            <a:off x="6814820" y="259079"/>
+            <a:ext cx="2075180" cy="287020"/>
           </a:xfrm>
           <a:prstGeom prst="roundRect">
             <a:avLst>
@@ -55304,7 +55039,7 @@
                 </a:solidFill>
                 <a:latin typeface="Inter"/>
               </a:rPr>
-              <a:t>ПЕРЕИСПОЛЬЗУЕМОСТЬ</a:t>
+              <a:t>РАЗБОР ОШИБОК</a:t>
             </a:r>
           </a:p>
         </p:txBody>
@@ -55339,54 +55074,21 @@
                 </a:solidFill>
                 <a:latin typeface="Montserrat"/>
               </a:rPr>
-              <a:t>Как мгновенно изменить цветовую тему проекта заменой одной строчки в :root?</a:t>
-            </a:r>
-          </a:p>
-        </p:txBody>
-      </p:sp>
-      <p:sp>
-        <p:nvSpPr>
-          <p:cNvPr id="4" name="Rounded Rectangle 3"/>
-          <p:cNvSpPr/>
-          <p:nvPr/>
-        </p:nvSpPr>
-        <p:spPr>
-          <a:xfrm>
-            <a:off x="304800" y="711200"/>
-            <a:ext cx="4127500" cy="3784600"/>
-          </a:xfrm>
-          <a:prstGeom prst="roundRect">
-            <a:avLst>
-              <a:gd name="adj" fmla="val 4000"/>
-            </a:avLst>
-          </a:prstGeom>
-          <a:solidFill>
-            <a:srgbClr val="181A1F"/>
-          </a:solidFill>
-          <a:ln w="12700">
-            <a:solidFill>
-              <a:srgbClr val="2D3139"/>
-            </a:solidFill>
-          </a:ln>
-        </p:spPr>
-        <p:txBody>
-          <a:bodyPr rtlCol="0" anchor="ctr"/>
-          <a:lstStyle/>
-          <a:p>
-            <a:pPr algn="ctr"/>
-          </a:p>
-        </p:txBody>
-      </p:sp>
-      <p:sp>
-        <p:nvSpPr>
-          <p:cNvPr id="5" name="TextBox 4"/>
+              <a:t>На чем чаще всего спотыкаются студенты при первой верстке сеток и карточек?</a:t>
+            </a:r>
+          </a:p>
+        </p:txBody>
+      </p:sp>
+      <p:sp>
+        <p:nvSpPr>
+          <p:cNvPr id="4" name="TextBox 3"/>
           <p:cNvSpPr txBox="1"/>
           <p:nvPr/>
         </p:nvSpPr>
         <p:spPr>
           <a:xfrm>
-            <a:off x="482600" y="812800"/>
-            <a:ext cx="3746500" cy="228600"/>
+            <a:off x="355600" y="787400"/>
+            <a:ext cx="4064000" cy="254000"/>
           </a:xfrm>
           <a:prstGeom prst="rect">
             <a:avLst/>
@@ -55400,27 +55102,27 @@
           <a:lstStyle/>
           <a:p>
             <a:r>
-              <a:rPr sz="900" b="1">
-                <a:solidFill>
-                  <a:srgbClr val="93C5FD"/>
-                </a:solidFill>
-                <a:latin typeface="Consolas"/>
-              </a:rPr>
-              <a:t>📄 css/style.css (Динамические темы)</a:t>
-            </a:r>
-          </a:p>
-        </p:txBody>
-      </p:sp>
-      <p:sp>
-        <p:nvSpPr>
-          <p:cNvPr id="6" name="Rectangle 5"/>
+              <a:rPr sz="1050" b="1">
+                <a:solidFill>
+                  <a:srgbClr val="FF6F03"/>
+                </a:solidFill>
+                <a:latin typeface="Montserrat"/>
+              </a:rPr>
+              <a:t>1. Сплющенные и растянутые фото</a:t>
+            </a:r>
+          </a:p>
+        </p:txBody>
+      </p:sp>
+      <p:sp>
+        <p:nvSpPr>
+          <p:cNvPr id="5" name="Rectangle 4"/>
           <p:cNvSpPr/>
           <p:nvPr/>
         </p:nvSpPr>
         <p:spPr>
           <a:xfrm>
-            <a:off x="457200" y="1066800"/>
-            <a:ext cx="3822700" cy="12700"/>
+            <a:off x="355600" y="1066800"/>
+            <a:ext cx="4064000" cy="12700"/>
           </a:xfrm>
           <a:prstGeom prst="rect">
             <a:avLst/>
@@ -55442,14 +55144,14 @@
       </p:sp>
       <p:sp>
         <p:nvSpPr>
-          <p:cNvPr id="7" name="TextBox 6"/>
+          <p:cNvPr id="6" name="TextBox 5"/>
           <p:cNvSpPr txBox="1"/>
           <p:nvPr/>
         </p:nvSpPr>
         <p:spPr>
           <a:xfrm>
-            <a:off x="457200" y="1143000"/>
-            <a:ext cx="3822700" cy="3251200"/>
+            <a:off x="355600" y="1168400"/>
+            <a:ext cx="4064000" cy="1219200"/>
           </a:xfrm>
           <a:prstGeom prst="rect">
             <a:avLst/>
@@ -55463,579 +55165,69 @@
           <a:lstStyle/>
           <a:p>
             <a:pPr>
-              <a:lnSpc>
-                <a:spcPct val="105000"/>
-              </a:lnSpc>
-              <a:spcBef>
-                <a:spcPts val="0"/>
-              </a:spcBef>
-              <a:spcAft>
-                <a:spcPts val="100"/>
-              </a:spcAft>
-            </a:pPr>
-            <a:r>
-              <a:rPr sz="800">
-                <a:solidFill>
-                  <a:srgbClr val="71717A"/>
-                </a:solidFill>
-                <a:latin typeface="Consolas"/>
-              </a:rPr>
-              <a:t>/* Базовая тема (СмартОфис) */</a:t>
-            </a:r>
-          </a:p>
-          <a:p>
-            <a:pPr>
-              <a:lnSpc>
-                <a:spcPct val="105000"/>
-              </a:lnSpc>
-              <a:spcBef>
-                <a:spcPts val="0"/>
-              </a:spcBef>
-              <a:spcAft>
-                <a:spcPts val="100"/>
-              </a:spcAft>
-            </a:pPr>
-            <a:r>
-              <a:rPr sz="800">
-                <a:solidFill>
-                  <a:srgbClr val="F472B6"/>
-                </a:solidFill>
-                <a:latin typeface="Consolas"/>
-              </a:rPr>
-              <a:t>:root </a:t>
-            </a:r>
-            <a:r>
-              <a:rPr sz="800">
-                <a:solidFill>
-                  <a:srgbClr val="D4D4D8"/>
-                </a:solidFill>
-                <a:latin typeface="Consolas"/>
-              </a:rPr>
-              <a:t>{</a:t>
-            </a:r>
-          </a:p>
-          <a:p>
-            <a:pPr>
-              <a:lnSpc>
-                <a:spcPct val="105000"/>
-              </a:lnSpc>
-              <a:spcBef>
-                <a:spcPts val="0"/>
-              </a:spcBef>
-              <a:spcAft>
-                <a:spcPts val="100"/>
-              </a:spcAft>
-            </a:pPr>
-            <a:r>
-              <a:rPr sz="800">
-                <a:solidFill>
-                  <a:srgbClr val="A78BFA"/>
-                </a:solidFill>
-                <a:latin typeface="Consolas"/>
-              </a:rPr>
-              <a:t>  --primary-color</a:t>
-            </a:r>
-            <a:r>
-              <a:rPr sz="800">
-                <a:solidFill>
-                  <a:srgbClr val="D4D4D8"/>
-                </a:solidFill>
-                <a:latin typeface="Consolas"/>
-              </a:rPr>
-              <a:t>: </a:t>
-            </a:r>
-            <a:r>
-              <a:rPr sz="800">
-                <a:solidFill>
-                  <a:srgbClr val="4ADE80"/>
-                </a:solidFill>
-                <a:latin typeface="Consolas"/>
-              </a:rPr>
-              <a:t>#007bff</a:t>
-            </a:r>
-            <a:r>
-              <a:rPr sz="800">
-                <a:solidFill>
-                  <a:srgbClr val="D4D4D8"/>
-                </a:solidFill>
-                <a:latin typeface="Consolas"/>
-              </a:rPr>
-              <a:t>;</a:t>
-            </a:r>
-          </a:p>
-          <a:p>
-            <a:pPr>
-              <a:lnSpc>
-                <a:spcPct val="105000"/>
-              </a:lnSpc>
-              <a:spcBef>
-                <a:spcPts val="0"/>
-              </a:spcBef>
-              <a:spcAft>
-                <a:spcPts val="100"/>
-              </a:spcAft>
-            </a:pPr>
-            <a:r>
-              <a:rPr sz="800">
-                <a:solidFill>
-                  <a:srgbClr val="A78BFA"/>
-                </a:solidFill>
-                <a:latin typeface="Consolas"/>
-              </a:rPr>
-              <a:t>  --primary-hover</a:t>
-            </a:r>
-            <a:r>
-              <a:rPr sz="800">
-                <a:solidFill>
-                  <a:srgbClr val="D4D4D8"/>
-                </a:solidFill>
-                <a:latin typeface="Consolas"/>
-              </a:rPr>
-              <a:t>: </a:t>
-            </a:r>
-            <a:r>
-              <a:rPr sz="800">
-                <a:solidFill>
-                  <a:srgbClr val="4ADE80"/>
-                </a:solidFill>
-                <a:latin typeface="Consolas"/>
-              </a:rPr>
-              <a:t>#0056b3</a:t>
-            </a:r>
-            <a:r>
-              <a:rPr sz="800">
-                <a:solidFill>
-                  <a:srgbClr val="D4D4D8"/>
-                </a:solidFill>
-                <a:latin typeface="Consolas"/>
-              </a:rPr>
-              <a:t>;</a:t>
-            </a:r>
-          </a:p>
-          <a:p>
-            <a:pPr>
-              <a:lnSpc>
-                <a:spcPct val="105000"/>
-              </a:lnSpc>
-              <a:spcBef>
-                <a:spcPts val="0"/>
-              </a:spcBef>
-              <a:spcAft>
-                <a:spcPts val="100"/>
-              </a:spcAft>
-            </a:pPr>
-            <a:r>
-              <a:rPr sz="800">
-                <a:solidFill>
-                  <a:srgbClr val="D4D4D8"/>
-                </a:solidFill>
-                <a:latin typeface="Consolas"/>
-              </a:rPr>
-              <a:t>}</a:t>
-            </a:r>
-          </a:p>
-          <a:p>
-            <a:pPr>
-              <a:lnSpc>
-                <a:spcPct val="105000"/>
-              </a:lnSpc>
-              <a:spcBef>
-                <a:spcPts val="0"/>
-              </a:spcBef>
-              <a:spcAft>
-                <a:spcPts val="100"/>
-              </a:spcAft>
-            </a:pPr>
-            <a:r>
-              <a:rPr sz="800">
-                <a:solidFill>
-                  <a:srgbClr val="D4D4D8"/>
-                </a:solidFill>
-                <a:latin typeface="Consolas"/>
-              </a:rPr>
-              <a:t/>
-            </a:r>
-          </a:p>
-          <a:p>
-            <a:pPr>
-              <a:lnSpc>
-                <a:spcPct val="105000"/>
-              </a:lnSpc>
-              <a:spcBef>
-                <a:spcPts val="0"/>
-              </a:spcBef>
-              <a:spcAft>
-                <a:spcPts val="100"/>
-              </a:spcAft>
-            </a:pPr>
-            <a:r>
-              <a:rPr sz="800">
-                <a:solidFill>
-                  <a:srgbClr val="71717A"/>
-                </a:solidFill>
-                <a:latin typeface="Consolas"/>
-              </a:rPr>
-              <a:t>/* Тема 'Изумрудный Коворкинг' */</a:t>
-            </a:r>
-          </a:p>
-          <a:p>
-            <a:pPr>
-              <a:lnSpc>
-                <a:spcPct val="105000"/>
-              </a:lnSpc>
-              <a:spcBef>
-                <a:spcPts val="0"/>
-              </a:spcBef>
-              <a:spcAft>
-                <a:spcPts val="100"/>
-              </a:spcAft>
-            </a:pPr>
-            <a:r>
-              <a:rPr sz="800">
-                <a:solidFill>
-                  <a:srgbClr val="F472B6"/>
-                </a:solidFill>
-                <a:latin typeface="Consolas"/>
-              </a:rPr>
-              <a:t>body.theme-emerald </a:t>
-            </a:r>
-            <a:r>
-              <a:rPr sz="800">
-                <a:solidFill>
-                  <a:srgbClr val="D4D4D8"/>
-                </a:solidFill>
-                <a:latin typeface="Consolas"/>
-              </a:rPr>
-              <a:t>{</a:t>
-            </a:r>
-          </a:p>
-          <a:p>
-            <a:pPr>
-              <a:lnSpc>
-                <a:spcPct val="105000"/>
-              </a:lnSpc>
-              <a:spcBef>
-                <a:spcPts val="0"/>
-              </a:spcBef>
-              <a:spcAft>
-                <a:spcPts val="100"/>
-              </a:spcAft>
-            </a:pPr>
-            <a:r>
-              <a:rPr sz="800">
-                <a:solidFill>
-                  <a:srgbClr val="A78BFA"/>
-                </a:solidFill>
-                <a:latin typeface="Consolas"/>
-              </a:rPr>
-              <a:t>  --primary-color</a:t>
-            </a:r>
-            <a:r>
-              <a:rPr sz="800">
-                <a:solidFill>
-                  <a:srgbClr val="D4D4D8"/>
-                </a:solidFill>
-                <a:latin typeface="Consolas"/>
-              </a:rPr>
-              <a:t>: </a:t>
-            </a:r>
-            <a:r>
-              <a:rPr sz="800">
-                <a:solidFill>
-                  <a:srgbClr val="4ADE80"/>
-                </a:solidFill>
-                <a:latin typeface="Consolas"/>
-              </a:rPr>
-              <a:t>#10b981</a:t>
-            </a:r>
-            <a:r>
-              <a:rPr sz="800">
-                <a:solidFill>
-                  <a:srgbClr val="D4D4D8"/>
-                </a:solidFill>
-                <a:latin typeface="Consolas"/>
-              </a:rPr>
-              <a:t>;</a:t>
-            </a:r>
-          </a:p>
-          <a:p>
-            <a:pPr>
-              <a:lnSpc>
-                <a:spcPct val="105000"/>
-              </a:lnSpc>
-              <a:spcBef>
-                <a:spcPts val="0"/>
-              </a:spcBef>
-              <a:spcAft>
-                <a:spcPts val="100"/>
-              </a:spcAft>
-            </a:pPr>
-            <a:r>
-              <a:rPr sz="800">
-                <a:solidFill>
-                  <a:srgbClr val="A78BFA"/>
-                </a:solidFill>
-                <a:latin typeface="Consolas"/>
-              </a:rPr>
-              <a:t>  --primary-hover</a:t>
-            </a:r>
-            <a:r>
-              <a:rPr sz="800">
-                <a:solidFill>
-                  <a:srgbClr val="D4D4D8"/>
-                </a:solidFill>
-                <a:latin typeface="Consolas"/>
-              </a:rPr>
-              <a:t>: </a:t>
-            </a:r>
-            <a:r>
-              <a:rPr sz="800">
-                <a:solidFill>
-                  <a:srgbClr val="4ADE80"/>
-                </a:solidFill>
-                <a:latin typeface="Consolas"/>
-              </a:rPr>
-              <a:t>#059669</a:t>
-            </a:r>
-            <a:r>
-              <a:rPr sz="800">
-                <a:solidFill>
-                  <a:srgbClr val="D4D4D8"/>
-                </a:solidFill>
-                <a:latin typeface="Consolas"/>
-              </a:rPr>
-              <a:t>;</a:t>
-            </a:r>
-          </a:p>
-          <a:p>
-            <a:pPr>
-              <a:lnSpc>
-                <a:spcPct val="105000"/>
-              </a:lnSpc>
-              <a:spcBef>
-                <a:spcPts val="0"/>
-              </a:spcBef>
-              <a:spcAft>
-                <a:spcPts val="100"/>
-              </a:spcAft>
-            </a:pPr>
-            <a:r>
-              <a:rPr sz="800">
-                <a:solidFill>
-                  <a:srgbClr val="D4D4D8"/>
-                </a:solidFill>
-                <a:latin typeface="Consolas"/>
-              </a:rPr>
-              <a:t>}</a:t>
-            </a:r>
-          </a:p>
-          <a:p>
-            <a:pPr>
-              <a:lnSpc>
-                <a:spcPct val="105000"/>
-              </a:lnSpc>
-              <a:spcBef>
-                <a:spcPts val="0"/>
-              </a:spcBef>
-              <a:spcAft>
-                <a:spcPts val="100"/>
-              </a:spcAft>
-            </a:pPr>
-            <a:r>
-              <a:rPr sz="800">
-                <a:solidFill>
-                  <a:srgbClr val="D4D4D8"/>
-                </a:solidFill>
-                <a:latin typeface="Consolas"/>
-              </a:rPr>
-              <a:t/>
-            </a:r>
-          </a:p>
-          <a:p>
-            <a:pPr>
-              <a:lnSpc>
-                <a:spcPct val="105000"/>
-              </a:lnSpc>
-              <a:spcBef>
-                <a:spcPts val="0"/>
-              </a:spcBef>
-              <a:spcAft>
-                <a:spcPts val="100"/>
-              </a:spcAft>
-            </a:pPr>
-            <a:r>
-              <a:rPr sz="800">
-                <a:solidFill>
-                  <a:srgbClr val="71717A"/>
-                </a:solidFill>
-                <a:latin typeface="Consolas"/>
-              </a:rPr>
-              <a:t>/* Тема 'Премиум Фиолетовый' */</a:t>
-            </a:r>
-          </a:p>
-          <a:p>
-            <a:pPr>
-              <a:lnSpc>
-                <a:spcPct val="105000"/>
-              </a:lnSpc>
-              <a:spcBef>
-                <a:spcPts val="0"/>
-              </a:spcBef>
-              <a:spcAft>
-                <a:spcPts val="100"/>
-              </a:spcAft>
-            </a:pPr>
-            <a:r>
-              <a:rPr sz="800">
-                <a:solidFill>
-                  <a:srgbClr val="F472B6"/>
-                </a:solidFill>
-                <a:latin typeface="Consolas"/>
-              </a:rPr>
-              <a:t>body.theme-purple </a:t>
-            </a:r>
-            <a:r>
-              <a:rPr sz="800">
-                <a:solidFill>
-                  <a:srgbClr val="D4D4D8"/>
-                </a:solidFill>
-                <a:latin typeface="Consolas"/>
-              </a:rPr>
-              <a:t>{</a:t>
-            </a:r>
-          </a:p>
-          <a:p>
-            <a:pPr>
-              <a:lnSpc>
-                <a:spcPct val="105000"/>
-              </a:lnSpc>
-              <a:spcBef>
-                <a:spcPts val="0"/>
-              </a:spcBef>
-              <a:spcAft>
-                <a:spcPts val="100"/>
-              </a:spcAft>
-            </a:pPr>
-            <a:r>
-              <a:rPr sz="800">
-                <a:solidFill>
-                  <a:srgbClr val="A78BFA"/>
-                </a:solidFill>
-                <a:latin typeface="Consolas"/>
-              </a:rPr>
-              <a:t>  --primary-color</a:t>
-            </a:r>
-            <a:r>
-              <a:rPr sz="800">
-                <a:solidFill>
-                  <a:srgbClr val="D4D4D8"/>
-                </a:solidFill>
-                <a:latin typeface="Consolas"/>
-              </a:rPr>
-              <a:t>: </a:t>
-            </a:r>
-            <a:r>
-              <a:rPr sz="800">
-                <a:solidFill>
-                  <a:srgbClr val="4ADE80"/>
-                </a:solidFill>
-                <a:latin typeface="Consolas"/>
-              </a:rPr>
-              <a:t>#8b5cf6</a:t>
-            </a:r>
-            <a:r>
-              <a:rPr sz="800">
-                <a:solidFill>
-                  <a:srgbClr val="D4D4D8"/>
-                </a:solidFill>
-                <a:latin typeface="Consolas"/>
-              </a:rPr>
-              <a:t>;</a:t>
-            </a:r>
-          </a:p>
-          <a:p>
-            <a:pPr>
-              <a:lnSpc>
-                <a:spcPct val="105000"/>
-              </a:lnSpc>
-              <a:spcBef>
-                <a:spcPts val="0"/>
-              </a:spcBef>
-              <a:spcAft>
-                <a:spcPts val="100"/>
-              </a:spcAft>
-            </a:pPr>
-            <a:r>
-              <a:rPr sz="800">
-                <a:solidFill>
-                  <a:srgbClr val="A78BFA"/>
-                </a:solidFill>
-                <a:latin typeface="Consolas"/>
-              </a:rPr>
-              <a:t>  --primary-hover</a:t>
-            </a:r>
-            <a:r>
-              <a:rPr sz="800">
-                <a:solidFill>
-                  <a:srgbClr val="D4D4D8"/>
-                </a:solidFill>
-                <a:latin typeface="Consolas"/>
-              </a:rPr>
-              <a:t>: </a:t>
-            </a:r>
-            <a:r>
-              <a:rPr sz="800">
-                <a:solidFill>
-                  <a:srgbClr val="4ADE80"/>
-                </a:solidFill>
-                <a:latin typeface="Consolas"/>
-              </a:rPr>
-              <a:t>#7c3aed</a:t>
-            </a:r>
-            <a:r>
-              <a:rPr sz="800">
-                <a:solidFill>
-                  <a:srgbClr val="D4D4D8"/>
-                </a:solidFill>
-                <a:latin typeface="Consolas"/>
-              </a:rPr>
-              <a:t>;</a:t>
-            </a:r>
-          </a:p>
-          <a:p>
-            <a:pPr>
-              <a:lnSpc>
-                <a:spcPct val="105000"/>
-              </a:lnSpc>
-              <a:spcBef>
-                <a:spcPts val="0"/>
-              </a:spcBef>
-              <a:spcAft>
-                <a:spcPts val="100"/>
-              </a:spcAft>
-            </a:pPr>
-            <a:r>
-              <a:rPr sz="800">
-                <a:solidFill>
-                  <a:srgbClr val="D4D4D8"/>
-                </a:solidFill>
-                <a:latin typeface="Consolas"/>
-              </a:rPr>
-              <a:t>}</a:t>
-            </a:r>
-          </a:p>
-        </p:txBody>
-      </p:sp>
-      <p:sp>
-        <p:nvSpPr>
-          <p:cNvPr id="8" name="TextBox 7"/>
+              <a:spcAft>
+                <a:spcPts val="400"/>
+              </a:spcAft>
+            </a:pPr>
+            <a:r>
+              <a:rPr sz="850" b="1">
+                <a:solidFill>
+                  <a:srgbClr val="222222"/>
+                </a:solidFill>
+                <a:latin typeface="Inter"/>
+              </a:rPr>
+              <a:t>Ошибка: </a:t>
+            </a:r>
+            <a:r>
+              <a:rPr sz="850">
+                <a:solidFill>
+                  <a:srgbClr val="444444"/>
+                </a:solidFill>
+                <a:latin typeface="Inter"/>
+              </a:rPr>
+              <a:t>Задание жестких width: 100% и height: 200px тегу &lt;img&gt; без свойства object-fit искажает естественные пропорции интерьеров.</a:t>
+            </a:r>
+          </a:p>
+          <a:p>
+            <a:pPr>
+              <a:lnSpc>
+                <a:spcPct val="115000"/>
+              </a:lnSpc>
+              <a:spcAft>
+                <a:spcPts val="0"/>
+              </a:spcAft>
+            </a:pPr>
+            <a:r>
+              <a:rPr sz="850" b="1">
+                <a:solidFill>
+                  <a:srgbClr val="16A34A"/>
+                </a:solidFill>
+                <a:latin typeface="Inter"/>
+              </a:rPr>
+              <a:t>Решение: </a:t>
+            </a:r>
+            <a:r>
+              <a:rPr sz="850">
+                <a:solidFill>
+                  <a:srgbClr val="444444"/>
+                </a:solidFill>
+                <a:latin typeface="Inter"/>
+              </a:rPr>
+              <a:t>Всегда оборачивать картинку в .card-img-wrap и задавать object-fit: cover с display: block.</a:t>
+            </a:r>
+          </a:p>
+        </p:txBody>
+      </p:sp>
+      <p:sp>
+        <p:nvSpPr>
+          <p:cNvPr id="7" name="TextBox 6"/>
           <p:cNvSpPr txBox="1"/>
           <p:nvPr/>
         </p:nvSpPr>
         <p:spPr>
           <a:xfrm>
-            <a:off x="4749800" y="685800"/>
-            <a:ext cx="4089400" cy="355600"/>
+            <a:off x="4724400" y="787400"/>
+            <a:ext cx="4064000" cy="254000"/>
           </a:xfrm>
           <a:prstGeom prst="rect">
             <a:avLst/>
@@ -56048,33 +55240,28 @@
           </a:bodyPr>
           <a:lstStyle/>
           <a:p>
-            <a:pPr>
-              <a:lnSpc>
-                <a:spcPct val="105000"/>
-              </a:lnSpc>
-            </a:pPr>
-            <a:r>
-              <a:rPr sz="1000" b="1">
+            <a:r>
+              <a:rPr sz="1050" b="1">
                 <a:solidFill>
                   <a:srgbClr val="FF6F03"/>
                 </a:solidFill>
                 <a:latin typeface="Montserrat"/>
               </a:rPr>
-              <a:t>КАСКАД ПЕРЕМЕННЫХ И WHITE-LABEL АРХИТЕКТУРА</a:t>
-            </a:r>
-          </a:p>
-        </p:txBody>
-      </p:sp>
-      <p:sp>
-        <p:nvSpPr>
-          <p:cNvPr id="9" name="Rectangle 8"/>
+              <a:t>2. «Пляшущие» кнопки в футере</a:t>
+            </a:r>
+          </a:p>
+        </p:txBody>
+      </p:sp>
+      <p:sp>
+        <p:nvSpPr>
+          <p:cNvPr id="8" name="Rectangle 7"/>
           <p:cNvSpPr/>
           <p:nvPr/>
         </p:nvSpPr>
         <p:spPr>
           <a:xfrm>
-            <a:off x="4749800" y="1079500"/>
-            <a:ext cx="4089400" cy="12700"/>
+            <a:off x="4724400" y="1066800"/>
+            <a:ext cx="4064000" cy="12700"/>
           </a:xfrm>
           <a:prstGeom prst="rect">
             <a:avLst/>
@@ -56096,22 +55283,130 @@
       </p:sp>
       <p:sp>
         <p:nvSpPr>
-          <p:cNvPr id="10" name="Rounded Rectangle Dot 0"/>
+          <p:cNvPr id="9" name="TextBox 8"/>
+          <p:cNvSpPr txBox="1"/>
+          <p:nvPr/>
+        </p:nvSpPr>
+        <p:spPr>
+          <a:xfrm>
+            <a:off x="4724400" y="1168400"/>
+            <a:ext cx="4064000" cy="1219200"/>
+          </a:xfrm>
+          <a:prstGeom prst="rect">
+            <a:avLst/>
+          </a:prstGeom>
+          <a:noFill/>
+        </p:spPr>
+        <p:txBody>
+          <a:bodyPr wrap="square" lIns="0" tIns="0" rIns="0" bIns="0">
+            <a:spAutoFit/>
+          </a:bodyPr>
+          <a:lstStyle/>
+          <a:p>
+            <a:pPr>
+              <a:spcAft>
+                <a:spcPts val="400"/>
+              </a:spcAft>
+            </a:pPr>
+            <a:r>
+              <a:rPr sz="850" b="1">
+                <a:solidFill>
+                  <a:srgbClr val="222222"/>
+                </a:solidFill>
+                <a:latin typeface="Inter"/>
+              </a:rPr>
+              <a:t>Ошибка: </a:t>
+            </a:r>
+            <a:r>
+              <a:rPr sz="850">
+                <a:solidFill>
+                  <a:srgbClr val="444444"/>
+                </a:solidFill>
+                <a:latin typeface="Inter"/>
+              </a:rPr>
+              <a:t>Из-за разного количества строк в описании футеры карточек находятся на разной высоте, ломая нижнюю линию витрины.</a:t>
+            </a:r>
+          </a:p>
+          <a:p>
+            <a:pPr>
+              <a:lnSpc>
+                <a:spcPct val="115000"/>
+              </a:lnSpc>
+              <a:spcAft>
+                <a:spcPts val="0"/>
+              </a:spcAft>
+            </a:pPr>
+            <a:r>
+              <a:rPr sz="850" b="1">
+                <a:solidFill>
+                  <a:srgbClr val="16A34A"/>
+                </a:solidFill>
+                <a:latin typeface="Inter"/>
+              </a:rPr>
+              <a:t>Решение: </a:t>
+            </a:r>
+            <a:r>
+              <a:rPr sz="850">
+                <a:solidFill>
+                  <a:srgbClr val="444444"/>
+                </a:solidFill>
+                <a:latin typeface="Inter"/>
+              </a:rPr>
+              <a:t>Задать карточке flex-direction: column, а контенту или списку оборудования присвоить распорку flex: 1.</a:t>
+            </a:r>
+          </a:p>
+        </p:txBody>
+      </p:sp>
+      <p:sp>
+        <p:nvSpPr>
+          <p:cNvPr id="10" name="TextBox 9"/>
+          <p:cNvSpPr txBox="1"/>
+          <p:nvPr/>
+        </p:nvSpPr>
+        <p:spPr>
+          <a:xfrm>
+            <a:off x="355600" y="2717800"/>
+            <a:ext cx="4064000" cy="254000"/>
+          </a:xfrm>
+          <a:prstGeom prst="rect">
+            <a:avLst/>
+          </a:prstGeom>
+          <a:noFill/>
+        </p:spPr>
+        <p:txBody>
+          <a:bodyPr wrap="square" lIns="0" tIns="0" rIns="0" bIns="0">
+            <a:spAutoFit/>
+          </a:bodyPr>
+          <a:lstStyle/>
+          <a:p>
+            <a:r>
+              <a:rPr sz="1050" b="1">
+                <a:solidFill>
+                  <a:srgbClr val="FF6F03"/>
+                </a:solidFill>
+                <a:latin typeface="Montserrat"/>
+              </a:rPr>
+              <a:t>3. Выпадение карточки из строки</a:t>
+            </a:r>
+          </a:p>
+        </p:txBody>
+      </p:sp>
+      <p:sp>
+        <p:nvSpPr>
+          <p:cNvPr id="11" name="Rectangle 10"/>
           <p:cNvSpPr/>
           <p:nvPr/>
         </p:nvSpPr>
         <p:spPr>
           <a:xfrm>
-            <a:off x="4749800" y="1238250"/>
-            <a:ext cx="82550" cy="82550"/>
-          </a:xfrm>
-          <a:prstGeom prst="roundRect">
-            <a:avLst>
-              <a:gd name="adj" fmla="val 20000"/>
-            </a:avLst>
+            <a:off x="355600" y="2997200"/>
+            <a:ext cx="4064000" cy="12700"/>
+          </a:xfrm>
+          <a:prstGeom prst="rect">
+            <a:avLst/>
           </a:prstGeom>
           <a:solidFill>
-            <a:srgbClr val="FE6002"/>
+            <a:srgbClr val="FF6F03"/>
           </a:solidFill>
           <a:ln>
             <a:noFill/>
@@ -56127,14 +55422,14 @@
       </p:sp>
       <p:sp>
         <p:nvSpPr>
-          <p:cNvPr id="11" name="TextBox Bullet 0"/>
+          <p:cNvPr id="12" name="TextBox 11"/>
           <p:cNvSpPr txBox="1"/>
           <p:nvPr/>
         </p:nvSpPr>
         <p:spPr>
           <a:xfrm>
-            <a:off x="4940300" y="1193800"/>
-            <a:ext cx="3898900" cy="609600"/>
+            <a:off x="355600" y="3098800"/>
+            <a:ext cx="4064000" cy="1219200"/>
           </a:xfrm>
           <a:prstGeom prst="rect">
             <a:avLst/>
@@ -56149,58 +55444,108 @@
           <a:p>
             <a:pPr>
               <a:spcAft>
-                <a:spcPts val="200"/>
-              </a:spcAft>
-            </a:pPr>
-            <a:r>
-              <a:rPr sz="950" b="1">
+                <a:spcPts val="400"/>
+              </a:spcAft>
+            </a:pPr>
+            <a:r>
+              <a:rPr sz="850" b="1">
                 <a:solidFill>
                   <a:srgbClr val="222222"/>
                 </a:solidFill>
+                <a:latin typeface="Inter"/>
+              </a:rPr>
+              <a:t>Ошибка: </a:t>
+            </a:r>
+            <a:r>
+              <a:rPr sz="850">
+                <a:solidFill>
+                  <a:srgbClr val="444444"/>
+                </a:solidFill>
+                <a:latin typeface="Inter"/>
+              </a:rPr>
+              <a:t>При добавлении border: 1px или padding карточка расширяется на пару пикселей, и третья карточка падает во второй ряд.</a:t>
+            </a:r>
+          </a:p>
+          <a:p>
+            <a:pPr>
+              <a:lnSpc>
+                <a:spcPct val="115000"/>
+              </a:lnSpc>
+              <a:spcAft>
+                <a:spcPts val="0"/>
+              </a:spcAft>
+            </a:pPr>
+            <a:r>
+              <a:rPr sz="850" b="1">
+                <a:solidFill>
+                  <a:srgbClr val="16A34A"/>
+                </a:solidFill>
+                <a:latin typeface="Inter"/>
+              </a:rPr>
+              <a:t>Решение: </a:t>
+            </a:r>
+            <a:r>
+              <a:rPr sz="850">
+                <a:solidFill>
+                  <a:srgbClr val="444444"/>
+                </a:solidFill>
+                <a:latin typeface="Inter"/>
+              </a:rPr>
+              <a:t>Обязательно подключать box-sizing: border-box в сбросе стилей селектора * в начале файла CSS.</a:t>
+            </a:r>
+          </a:p>
+        </p:txBody>
+      </p:sp>
+      <p:sp>
+        <p:nvSpPr>
+          <p:cNvPr id="13" name="TextBox 12"/>
+          <p:cNvSpPr txBox="1"/>
+          <p:nvPr/>
+        </p:nvSpPr>
+        <p:spPr>
+          <a:xfrm>
+            <a:off x="4724400" y="2717800"/>
+            <a:ext cx="4064000" cy="254000"/>
+          </a:xfrm>
+          <a:prstGeom prst="rect">
+            <a:avLst/>
+          </a:prstGeom>
+          <a:noFill/>
+        </p:spPr>
+        <p:txBody>
+          <a:bodyPr wrap="square" lIns="0" tIns="0" rIns="0" bIns="0">
+            <a:spAutoFit/>
+          </a:bodyPr>
+          <a:lstStyle/>
+          <a:p>
+            <a:r>
+              <a:rPr sz="1050" b="1">
+                <a:solidFill>
+                  <a:srgbClr val="FF6F03"/>
+                </a:solidFill>
                 <a:latin typeface="Montserrat"/>
               </a:rPr>
-              <a:t>Локальное переопределение токенов:</a:t>
-            </a:r>
-          </a:p>
-          <a:p>
-            <a:pPr>
-              <a:lnSpc>
-                <a:spcPct val="115000"/>
-              </a:lnSpc>
-              <a:spcAft>
-                <a:spcPts val="0"/>
-              </a:spcAft>
-            </a:pPr>
-            <a:r>
-              <a:rPr sz="850">
-                <a:solidFill>
-                  <a:srgbClr val="444444"/>
-                </a:solidFill>
-                <a:latin typeface="Inter"/>
-              </a:rPr>
-              <a:t>Селектор body.theme-emerald переопределяет переменные для себя и всех дочерних элементов благодаря каскаду CSS.</a:t>
-            </a:r>
-          </a:p>
-        </p:txBody>
-      </p:sp>
-      <p:sp>
-        <p:nvSpPr>
-          <p:cNvPr id="12" name="Rounded Rectangle Dot 1"/>
+              <a:t>4. Жесткий height у блоков с текстом</a:t>
+            </a:r>
+          </a:p>
+        </p:txBody>
+      </p:sp>
+      <p:sp>
+        <p:nvSpPr>
+          <p:cNvPr id="14" name="Rectangle 13"/>
           <p:cNvSpPr/>
           <p:nvPr/>
         </p:nvSpPr>
         <p:spPr>
           <a:xfrm>
-            <a:off x="4749800" y="2025650"/>
-            <a:ext cx="82550" cy="82550"/>
-          </a:xfrm>
-          <a:prstGeom prst="roundRect">
-            <a:avLst>
-              <a:gd name="adj" fmla="val 20000"/>
-            </a:avLst>
+            <a:off x="4724400" y="2997200"/>
+            <a:ext cx="4064000" cy="12700"/>
+          </a:xfrm>
+          <a:prstGeom prst="rect">
+            <a:avLst/>
           </a:prstGeom>
           <a:solidFill>
-            <a:srgbClr val="FE6002"/>
+            <a:srgbClr val="FF6F03"/>
           </a:solidFill>
           <a:ln>
             <a:noFill/>
@@ -56216,14 +55561,14 @@
       </p:sp>
       <p:sp>
         <p:nvSpPr>
-          <p:cNvPr id="13" name="TextBox Bullet 1"/>
+          <p:cNvPr id="15" name="TextBox 14"/>
           <p:cNvSpPr txBox="1"/>
           <p:nvPr/>
         </p:nvSpPr>
         <p:spPr>
           <a:xfrm>
-            <a:off x="4940300" y="1981200"/>
-            <a:ext cx="3898900" cy="609600"/>
+            <a:off x="4724400" y="3098800"/>
+            <a:ext cx="4064000" cy="1219200"/>
           </a:xfrm>
           <a:prstGeom prst="rect">
             <a:avLst/>
@@ -56238,17 +55583,26 @@
           <a:p>
             <a:pPr>
               <a:spcAft>
-                <a:spcPts val="200"/>
-              </a:spcAft>
-            </a:pPr>
-            <a:r>
-              <a:rPr sz="950" b="1">
+                <a:spcPts val="400"/>
+              </a:spcAft>
+            </a:pPr>
+            <a:r>
+              <a:rPr sz="850" b="1">
                 <a:solidFill>
                   <a:srgbClr val="222222"/>
                 </a:solidFill>
-                <a:latin typeface="Montserrat"/>
-              </a:rPr>
-              <a:t>0% переписывания стилей компонентов:</a:t>
+                <a:latin typeface="Inter"/>
+              </a:rPr>
+              <a:t>Ошибка: </a:t>
+            </a:r>
+            <a:r>
+              <a:rPr sz="850">
+                <a:solidFill>
+                  <a:srgbClr val="444444"/>
+                </a:solidFill>
+                <a:latin typeface="Inter"/>
+              </a:rPr>
+              <a:t>Установка height: 100px для заголовка или списка оборудования приводит к обрезанию или вылезанию текста наружу.</a:t>
             </a:r>
           </a:p>
           <a:p>
@@ -56261,191 +55615,22 @@
               </a:spcAft>
             </a:pPr>
             <a:r>
+              <a:rPr sz="850" b="1">
+                <a:solidFill>
+                  <a:srgbClr val="16A34A"/>
+                </a:solidFill>
+                <a:latin typeface="Inter"/>
+              </a:rPr>
+              <a:t>Решение: </a:t>
+            </a:r>
+            <a:r>
               <a:rPr sz="850">
                 <a:solidFill>
                   <a:srgbClr val="444444"/>
                 </a:solidFill>
                 <a:latin typeface="Inter"/>
               </a:rPr>
-              <a:t>Кнопки, иконки, ссылки и фокусные рамки карточек читают var(--primary-color) и преображаются автоматически без единой правки.</a:t>
-            </a:r>
-          </a:p>
-        </p:txBody>
-      </p:sp>
-      <p:sp>
-        <p:nvSpPr>
-          <p:cNvPr id="14" name="Rounded Rectangle Dot 2"/>
-          <p:cNvSpPr/>
-          <p:nvPr/>
-        </p:nvSpPr>
-        <p:spPr>
-          <a:xfrm>
-            <a:off x="4749800" y="2813050"/>
-            <a:ext cx="82550" cy="82550"/>
-          </a:xfrm>
-          <a:prstGeom prst="roundRect">
-            <a:avLst>
-              <a:gd name="adj" fmla="val 20000"/>
-            </a:avLst>
-          </a:prstGeom>
-          <a:solidFill>
-            <a:srgbClr val="FE6002"/>
-          </a:solidFill>
-          <a:ln>
-            <a:noFill/>
-          </a:ln>
-        </p:spPr>
-        <p:txBody>
-          <a:bodyPr rtlCol="0" anchor="ctr"/>
-          <a:lstStyle/>
-          <a:p>
-            <a:pPr algn="ctr"/>
-          </a:p>
-        </p:txBody>
-      </p:sp>
-      <p:sp>
-        <p:nvSpPr>
-          <p:cNvPr id="15" name="TextBox Bullet 2"/>
-          <p:cNvSpPr txBox="1"/>
-          <p:nvPr/>
-        </p:nvSpPr>
-        <p:spPr>
-          <a:xfrm>
-            <a:off x="4940300" y="2768600"/>
-            <a:ext cx="3898900" cy="609600"/>
-          </a:xfrm>
-          <a:prstGeom prst="rect">
-            <a:avLst/>
-          </a:prstGeom>
-          <a:noFill/>
-        </p:spPr>
-        <p:txBody>
-          <a:bodyPr wrap="square" lIns="0" tIns="0" rIns="0" bIns="0">
-            <a:spAutoFit/>
-          </a:bodyPr>
-          <a:lstStyle/>
-          <a:p>
-            <a:pPr>
-              <a:spcAft>
-                <a:spcPts val="200"/>
-              </a:spcAft>
-            </a:pPr>
-            <a:r>
-              <a:rPr sz="950" b="1">
-                <a:solidFill>
-                  <a:srgbClr val="222222"/>
-                </a:solidFill>
-                <a:latin typeface="Montserrat"/>
-              </a:rPr>
-              <a:t>Основа White-label разработки:</a:t>
-            </a:r>
-          </a:p>
-          <a:p>
-            <a:pPr>
-              <a:lnSpc>
-                <a:spcPct val="115000"/>
-              </a:lnSpc>
-              <a:spcAft>
-                <a:spcPts val="0"/>
-              </a:spcAft>
-            </a:pPr>
-            <a:r>
-              <a:rPr sz="850">
-                <a:solidFill>
-                  <a:srgbClr val="444444"/>
-                </a:solidFill>
-                <a:latin typeface="Inter"/>
-              </a:rPr>
-              <a:t>Один и тот же движок бронирования офисов можно продавать разным заказчикам, меняя лишь файл переменных брендовой гаммы.</a:t>
-            </a:r>
-          </a:p>
-        </p:txBody>
-      </p:sp>
-      <p:sp>
-        <p:nvSpPr>
-          <p:cNvPr id="16" name="Rounded Rectangle Dot 3"/>
-          <p:cNvSpPr/>
-          <p:nvPr/>
-        </p:nvSpPr>
-        <p:spPr>
-          <a:xfrm>
-            <a:off x="4749800" y="3600450"/>
-            <a:ext cx="82550" cy="82550"/>
-          </a:xfrm>
-          <a:prstGeom prst="roundRect">
-            <a:avLst>
-              <a:gd name="adj" fmla="val 20000"/>
-            </a:avLst>
-          </a:prstGeom>
-          <a:solidFill>
-            <a:srgbClr val="FE6002"/>
-          </a:solidFill>
-          <a:ln>
-            <a:noFill/>
-          </a:ln>
-        </p:spPr>
-        <p:txBody>
-          <a:bodyPr rtlCol="0" anchor="ctr"/>
-          <a:lstStyle/>
-          <a:p>
-            <a:pPr algn="ctr"/>
-          </a:p>
-        </p:txBody>
-      </p:sp>
-      <p:sp>
-        <p:nvSpPr>
-          <p:cNvPr id="17" name="TextBox Bullet 3"/>
-          <p:cNvSpPr txBox="1"/>
-          <p:nvPr/>
-        </p:nvSpPr>
-        <p:spPr>
-          <a:xfrm>
-            <a:off x="4940300" y="3556000"/>
-            <a:ext cx="3898900" cy="609600"/>
-          </a:xfrm>
-          <a:prstGeom prst="rect">
-            <a:avLst/>
-          </a:prstGeom>
-          <a:noFill/>
-        </p:spPr>
-        <p:txBody>
-          <a:bodyPr wrap="square" lIns="0" tIns="0" rIns="0" bIns="0">
-            <a:spAutoFit/>
-          </a:bodyPr>
-          <a:lstStyle/>
-          <a:p>
-            <a:pPr>
-              <a:spcAft>
-                <a:spcPts val="200"/>
-              </a:spcAft>
-            </a:pPr>
-            <a:r>
-              <a:rPr sz="950" b="1">
-                <a:solidFill>
-                  <a:srgbClr val="222222"/>
-                </a:solidFill>
-                <a:latin typeface="Montserrat"/>
-              </a:rPr>
-              <a:t>Переключение в 1 строчку через JS:</a:t>
-            </a:r>
-          </a:p>
-          <a:p>
-            <a:pPr>
-              <a:lnSpc>
-                <a:spcPct val="115000"/>
-              </a:lnSpc>
-              <a:spcAft>
-                <a:spcPts val="0"/>
-              </a:spcAft>
-            </a:pPr>
-            <a:r>
-              <a:rPr sz="850">
-                <a:solidFill>
-                  <a:srgbClr val="444444"/>
-                </a:solidFill>
-                <a:latin typeface="Inter"/>
-              </a:rPr>
-              <a:t>В JavaScript достаточно выполнить document.body.className = 'theme-emerald', чтобы весь интерфейс сменил стиль прямо на лету!</a:t>
+              <a:t>Задавать только min-height, либо позволять флекс-распоркам автоматически распределять высоту по контенту.</a:t>
             </a:r>
           </a:p>
         </p:txBody>
@@ -56459,657 +55644,6 @@
 </file>
 
 <file path=ppt/slides/slide48.xml><?xml version="1.0" encoding="utf-8"?>
-<p:sld xmlns:a="http://schemas.openxmlformats.org/drawingml/2006/main" xmlns:p="http://schemas.openxmlformats.org/presentationml/2006/main" xmlns:r="http://schemas.openxmlformats.org/officeDocument/2006/relationships">
-  <p:cSld>
-    <p:spTree>
-      <p:nvGrpSpPr>
-        <p:cNvPr id="1" name=""/>
-        <p:cNvGrpSpPr/>
-        <p:nvPr/>
-      </p:nvGrpSpPr>
-      <p:grpSpPr/>
-      <p:sp>
-        <p:nvSpPr>
-          <p:cNvPr id="2" name="Google Shape;69;p14"/>
-          <p:cNvSpPr/>
-          <p:nvPr/>
-        </p:nvSpPr>
-        <p:spPr>
-          <a:xfrm>
-            <a:off x="6814820" y="259079"/>
-            <a:ext cx="2075180" cy="287020"/>
-          </a:xfrm>
-          <a:prstGeom prst="roundRect">
-            <a:avLst>
-              <a:gd name="adj" fmla="val 50000"/>
-            </a:avLst>
-          </a:prstGeom>
-          <a:solidFill>
-            <a:srgbClr val="FE6002"/>
-          </a:solidFill>
-          <a:ln w="9525">
-            <a:solidFill>
-              <a:srgbClr val="EEEEEE"/>
-            </a:solidFill>
-          </a:ln>
-        </p:spPr>
-        <p:txBody>
-          <a:bodyPr rtlCol="0" anchor="ctr" wrap="none" lIns="0" tIns="0" rIns="0" bIns="0"/>
-          <a:lstStyle/>
-          <a:p>
-            <a:pPr algn="ctr"/>
-            <a:r>
-              <a:rPr sz="1200" b="0">
-                <a:solidFill>
-                  <a:srgbClr val="FFFFFF"/>
-                </a:solidFill>
-                <a:latin typeface="Inter"/>
-              </a:rPr>
-              <a:t>РАЗБОР ОШИБОК</a:t>
-            </a:r>
-          </a:p>
-        </p:txBody>
-      </p:sp>
-      <p:sp>
-        <p:nvSpPr>
-          <p:cNvPr id="3" name="TextBox 2"/>
-          <p:cNvSpPr txBox="1"/>
-          <p:nvPr/>
-        </p:nvSpPr>
-        <p:spPr>
-          <a:xfrm>
-            <a:off x="306070" y="4674870"/>
-            <a:ext cx="6350000" cy="254000"/>
-          </a:xfrm>
-          <a:prstGeom prst="rect">
-            <a:avLst/>
-          </a:prstGeom>
-          <a:noFill/>
-        </p:spPr>
-        <p:txBody>
-          <a:bodyPr wrap="square" lIns="0" tIns="0" rIns="0" bIns="0">
-            <a:spAutoFit/>
-          </a:bodyPr>
-          <a:lstStyle/>
-          <a:p>
-            <a:pPr algn="l"/>
-            <a:r>
-              <a:rPr sz="1000">
-                <a:solidFill>
-                  <a:srgbClr val="A6A1A1"/>
-                </a:solidFill>
-                <a:latin typeface="Montserrat"/>
-              </a:rPr>
-              <a:t>На чем чаще всего спотыкаются студенты при первой верстке сеток и карточек?</a:t>
-            </a:r>
-          </a:p>
-        </p:txBody>
-      </p:sp>
-      <p:sp>
-        <p:nvSpPr>
-          <p:cNvPr id="4" name="TextBox 3"/>
-          <p:cNvSpPr txBox="1"/>
-          <p:nvPr/>
-        </p:nvSpPr>
-        <p:spPr>
-          <a:xfrm>
-            <a:off x="355600" y="787400"/>
-            <a:ext cx="4064000" cy="254000"/>
-          </a:xfrm>
-          <a:prstGeom prst="rect">
-            <a:avLst/>
-          </a:prstGeom>
-          <a:noFill/>
-        </p:spPr>
-        <p:txBody>
-          <a:bodyPr wrap="square" lIns="0" tIns="0" rIns="0" bIns="0">
-            <a:spAutoFit/>
-          </a:bodyPr>
-          <a:lstStyle/>
-          <a:p>
-            <a:r>
-              <a:rPr sz="1050" b="1">
-                <a:solidFill>
-                  <a:srgbClr val="FF6F03"/>
-                </a:solidFill>
-                <a:latin typeface="Montserrat"/>
-              </a:rPr>
-              <a:t>1. Сплющенные и растянутые фото</a:t>
-            </a:r>
-          </a:p>
-        </p:txBody>
-      </p:sp>
-      <p:sp>
-        <p:nvSpPr>
-          <p:cNvPr id="5" name="Rectangle 4"/>
-          <p:cNvSpPr/>
-          <p:nvPr/>
-        </p:nvSpPr>
-        <p:spPr>
-          <a:xfrm>
-            <a:off x="355600" y="1066800"/>
-            <a:ext cx="4064000" cy="12700"/>
-          </a:xfrm>
-          <a:prstGeom prst="rect">
-            <a:avLst/>
-          </a:prstGeom>
-          <a:solidFill>
-            <a:srgbClr val="FF6F03"/>
-          </a:solidFill>
-          <a:ln>
-            <a:noFill/>
-          </a:ln>
-        </p:spPr>
-        <p:txBody>
-          <a:bodyPr rtlCol="0" anchor="ctr"/>
-          <a:lstStyle/>
-          <a:p>
-            <a:pPr algn="ctr"/>
-          </a:p>
-        </p:txBody>
-      </p:sp>
-      <p:sp>
-        <p:nvSpPr>
-          <p:cNvPr id="6" name="TextBox 5"/>
-          <p:cNvSpPr txBox="1"/>
-          <p:nvPr/>
-        </p:nvSpPr>
-        <p:spPr>
-          <a:xfrm>
-            <a:off x="355600" y="1168400"/>
-            <a:ext cx="4064000" cy="1219200"/>
-          </a:xfrm>
-          <a:prstGeom prst="rect">
-            <a:avLst/>
-          </a:prstGeom>
-          <a:noFill/>
-        </p:spPr>
-        <p:txBody>
-          <a:bodyPr wrap="square" lIns="0" tIns="0" rIns="0" bIns="0">
-            <a:spAutoFit/>
-          </a:bodyPr>
-          <a:lstStyle/>
-          <a:p>
-            <a:pPr>
-              <a:spcAft>
-                <a:spcPts val="400"/>
-              </a:spcAft>
-            </a:pPr>
-            <a:r>
-              <a:rPr sz="850" b="1">
-                <a:solidFill>
-                  <a:srgbClr val="222222"/>
-                </a:solidFill>
-                <a:latin typeface="Inter"/>
-              </a:rPr>
-              <a:t>Ошибка: </a:t>
-            </a:r>
-            <a:r>
-              <a:rPr sz="850">
-                <a:solidFill>
-                  <a:srgbClr val="444444"/>
-                </a:solidFill>
-                <a:latin typeface="Inter"/>
-              </a:rPr>
-              <a:t>Задание жестких width: 100% и height: 200px тегу &lt;img&gt; без свойства object-fit искажает естественные пропорции интерьеров.</a:t>
-            </a:r>
-          </a:p>
-          <a:p>
-            <a:pPr>
-              <a:lnSpc>
-                <a:spcPct val="115000"/>
-              </a:lnSpc>
-              <a:spcAft>
-                <a:spcPts val="0"/>
-              </a:spcAft>
-            </a:pPr>
-            <a:r>
-              <a:rPr sz="850" b="1">
-                <a:solidFill>
-                  <a:srgbClr val="16A34A"/>
-                </a:solidFill>
-                <a:latin typeface="Inter"/>
-              </a:rPr>
-              <a:t>Решение: </a:t>
-            </a:r>
-            <a:r>
-              <a:rPr sz="850">
-                <a:solidFill>
-                  <a:srgbClr val="444444"/>
-                </a:solidFill>
-                <a:latin typeface="Inter"/>
-              </a:rPr>
-              <a:t>Всегда оборачивать картинку в .card-img-wrap и задавать object-fit: cover с display: block.</a:t>
-            </a:r>
-          </a:p>
-        </p:txBody>
-      </p:sp>
-      <p:sp>
-        <p:nvSpPr>
-          <p:cNvPr id="7" name="TextBox 6"/>
-          <p:cNvSpPr txBox="1"/>
-          <p:nvPr/>
-        </p:nvSpPr>
-        <p:spPr>
-          <a:xfrm>
-            <a:off x="4724400" y="787400"/>
-            <a:ext cx="4064000" cy="254000"/>
-          </a:xfrm>
-          <a:prstGeom prst="rect">
-            <a:avLst/>
-          </a:prstGeom>
-          <a:noFill/>
-        </p:spPr>
-        <p:txBody>
-          <a:bodyPr wrap="square" lIns="0" tIns="0" rIns="0" bIns="0">
-            <a:spAutoFit/>
-          </a:bodyPr>
-          <a:lstStyle/>
-          <a:p>
-            <a:r>
-              <a:rPr sz="1050" b="1">
-                <a:solidFill>
-                  <a:srgbClr val="FF6F03"/>
-                </a:solidFill>
-                <a:latin typeface="Montserrat"/>
-              </a:rPr>
-              <a:t>2. «Пляшущие» кнопки в футере</a:t>
-            </a:r>
-          </a:p>
-        </p:txBody>
-      </p:sp>
-      <p:sp>
-        <p:nvSpPr>
-          <p:cNvPr id="8" name="Rectangle 7"/>
-          <p:cNvSpPr/>
-          <p:nvPr/>
-        </p:nvSpPr>
-        <p:spPr>
-          <a:xfrm>
-            <a:off x="4724400" y="1066800"/>
-            <a:ext cx="4064000" cy="12700"/>
-          </a:xfrm>
-          <a:prstGeom prst="rect">
-            <a:avLst/>
-          </a:prstGeom>
-          <a:solidFill>
-            <a:srgbClr val="FF6F03"/>
-          </a:solidFill>
-          <a:ln>
-            <a:noFill/>
-          </a:ln>
-        </p:spPr>
-        <p:txBody>
-          <a:bodyPr rtlCol="0" anchor="ctr"/>
-          <a:lstStyle/>
-          <a:p>
-            <a:pPr algn="ctr"/>
-          </a:p>
-        </p:txBody>
-      </p:sp>
-      <p:sp>
-        <p:nvSpPr>
-          <p:cNvPr id="9" name="TextBox 8"/>
-          <p:cNvSpPr txBox="1"/>
-          <p:nvPr/>
-        </p:nvSpPr>
-        <p:spPr>
-          <a:xfrm>
-            <a:off x="4724400" y="1168400"/>
-            <a:ext cx="4064000" cy="1219200"/>
-          </a:xfrm>
-          <a:prstGeom prst="rect">
-            <a:avLst/>
-          </a:prstGeom>
-          <a:noFill/>
-        </p:spPr>
-        <p:txBody>
-          <a:bodyPr wrap="square" lIns="0" tIns="0" rIns="0" bIns="0">
-            <a:spAutoFit/>
-          </a:bodyPr>
-          <a:lstStyle/>
-          <a:p>
-            <a:pPr>
-              <a:spcAft>
-                <a:spcPts val="400"/>
-              </a:spcAft>
-            </a:pPr>
-            <a:r>
-              <a:rPr sz="850" b="1">
-                <a:solidFill>
-                  <a:srgbClr val="222222"/>
-                </a:solidFill>
-                <a:latin typeface="Inter"/>
-              </a:rPr>
-              <a:t>Ошибка: </a:t>
-            </a:r>
-            <a:r>
-              <a:rPr sz="850">
-                <a:solidFill>
-                  <a:srgbClr val="444444"/>
-                </a:solidFill>
-                <a:latin typeface="Inter"/>
-              </a:rPr>
-              <a:t>Из-за разного количества строк в описании футеры карточек находятся на разной высоте, ломая нижнюю линию витрины.</a:t>
-            </a:r>
-          </a:p>
-          <a:p>
-            <a:pPr>
-              <a:lnSpc>
-                <a:spcPct val="115000"/>
-              </a:lnSpc>
-              <a:spcAft>
-                <a:spcPts val="0"/>
-              </a:spcAft>
-            </a:pPr>
-            <a:r>
-              <a:rPr sz="850" b="1">
-                <a:solidFill>
-                  <a:srgbClr val="16A34A"/>
-                </a:solidFill>
-                <a:latin typeface="Inter"/>
-              </a:rPr>
-              <a:t>Решение: </a:t>
-            </a:r>
-            <a:r>
-              <a:rPr sz="850">
-                <a:solidFill>
-                  <a:srgbClr val="444444"/>
-                </a:solidFill>
-                <a:latin typeface="Inter"/>
-              </a:rPr>
-              <a:t>Задать карточке flex-direction: column, а контенту или списку оборудования присвоить распорку flex: 1.</a:t>
-            </a:r>
-          </a:p>
-        </p:txBody>
-      </p:sp>
-      <p:sp>
-        <p:nvSpPr>
-          <p:cNvPr id="10" name="TextBox 9"/>
-          <p:cNvSpPr txBox="1"/>
-          <p:nvPr/>
-        </p:nvSpPr>
-        <p:spPr>
-          <a:xfrm>
-            <a:off x="355600" y="2717800"/>
-            <a:ext cx="4064000" cy="254000"/>
-          </a:xfrm>
-          <a:prstGeom prst="rect">
-            <a:avLst/>
-          </a:prstGeom>
-          <a:noFill/>
-        </p:spPr>
-        <p:txBody>
-          <a:bodyPr wrap="square" lIns="0" tIns="0" rIns="0" bIns="0">
-            <a:spAutoFit/>
-          </a:bodyPr>
-          <a:lstStyle/>
-          <a:p>
-            <a:r>
-              <a:rPr sz="1050" b="1">
-                <a:solidFill>
-                  <a:srgbClr val="FF6F03"/>
-                </a:solidFill>
-                <a:latin typeface="Montserrat"/>
-              </a:rPr>
-              <a:t>3. Выпадение карточки из строки</a:t>
-            </a:r>
-          </a:p>
-        </p:txBody>
-      </p:sp>
-      <p:sp>
-        <p:nvSpPr>
-          <p:cNvPr id="11" name="Rectangle 10"/>
-          <p:cNvSpPr/>
-          <p:nvPr/>
-        </p:nvSpPr>
-        <p:spPr>
-          <a:xfrm>
-            <a:off x="355600" y="2997200"/>
-            <a:ext cx="4064000" cy="12700"/>
-          </a:xfrm>
-          <a:prstGeom prst="rect">
-            <a:avLst/>
-          </a:prstGeom>
-          <a:solidFill>
-            <a:srgbClr val="FF6F03"/>
-          </a:solidFill>
-          <a:ln>
-            <a:noFill/>
-          </a:ln>
-        </p:spPr>
-        <p:txBody>
-          <a:bodyPr rtlCol="0" anchor="ctr"/>
-          <a:lstStyle/>
-          <a:p>
-            <a:pPr algn="ctr"/>
-          </a:p>
-        </p:txBody>
-      </p:sp>
-      <p:sp>
-        <p:nvSpPr>
-          <p:cNvPr id="12" name="TextBox 11"/>
-          <p:cNvSpPr txBox="1"/>
-          <p:nvPr/>
-        </p:nvSpPr>
-        <p:spPr>
-          <a:xfrm>
-            <a:off x="355600" y="3098800"/>
-            <a:ext cx="4064000" cy="1219200"/>
-          </a:xfrm>
-          <a:prstGeom prst="rect">
-            <a:avLst/>
-          </a:prstGeom>
-          <a:noFill/>
-        </p:spPr>
-        <p:txBody>
-          <a:bodyPr wrap="square" lIns="0" tIns="0" rIns="0" bIns="0">
-            <a:spAutoFit/>
-          </a:bodyPr>
-          <a:lstStyle/>
-          <a:p>
-            <a:pPr>
-              <a:spcAft>
-                <a:spcPts val="400"/>
-              </a:spcAft>
-            </a:pPr>
-            <a:r>
-              <a:rPr sz="850" b="1">
-                <a:solidFill>
-                  <a:srgbClr val="222222"/>
-                </a:solidFill>
-                <a:latin typeface="Inter"/>
-              </a:rPr>
-              <a:t>Ошибка: </a:t>
-            </a:r>
-            <a:r>
-              <a:rPr sz="850">
-                <a:solidFill>
-                  <a:srgbClr val="444444"/>
-                </a:solidFill>
-                <a:latin typeface="Inter"/>
-              </a:rPr>
-              <a:t>При добавлении border: 1px или padding карточка расширяется на пару пикселей, и третья карточка падает во второй ряд.</a:t>
-            </a:r>
-          </a:p>
-          <a:p>
-            <a:pPr>
-              <a:lnSpc>
-                <a:spcPct val="115000"/>
-              </a:lnSpc>
-              <a:spcAft>
-                <a:spcPts val="0"/>
-              </a:spcAft>
-            </a:pPr>
-            <a:r>
-              <a:rPr sz="850" b="1">
-                <a:solidFill>
-                  <a:srgbClr val="16A34A"/>
-                </a:solidFill>
-                <a:latin typeface="Inter"/>
-              </a:rPr>
-              <a:t>Решение: </a:t>
-            </a:r>
-            <a:r>
-              <a:rPr sz="850">
-                <a:solidFill>
-                  <a:srgbClr val="444444"/>
-                </a:solidFill>
-                <a:latin typeface="Inter"/>
-              </a:rPr>
-              <a:t>Обязательно подключать box-sizing: border-box в сбросе стилей селектора * в начале файла CSS.</a:t>
-            </a:r>
-          </a:p>
-        </p:txBody>
-      </p:sp>
-      <p:sp>
-        <p:nvSpPr>
-          <p:cNvPr id="13" name="TextBox 12"/>
-          <p:cNvSpPr txBox="1"/>
-          <p:nvPr/>
-        </p:nvSpPr>
-        <p:spPr>
-          <a:xfrm>
-            <a:off x="4724400" y="2717800"/>
-            <a:ext cx="4064000" cy="254000"/>
-          </a:xfrm>
-          <a:prstGeom prst="rect">
-            <a:avLst/>
-          </a:prstGeom>
-          <a:noFill/>
-        </p:spPr>
-        <p:txBody>
-          <a:bodyPr wrap="square" lIns="0" tIns="0" rIns="0" bIns="0">
-            <a:spAutoFit/>
-          </a:bodyPr>
-          <a:lstStyle/>
-          <a:p>
-            <a:r>
-              <a:rPr sz="1050" b="1">
-                <a:solidFill>
-                  <a:srgbClr val="FF6F03"/>
-                </a:solidFill>
-                <a:latin typeface="Montserrat"/>
-              </a:rPr>
-              <a:t>4. Жесткий height у блоков с текстом</a:t>
-            </a:r>
-          </a:p>
-        </p:txBody>
-      </p:sp>
-      <p:sp>
-        <p:nvSpPr>
-          <p:cNvPr id="14" name="Rectangle 13"/>
-          <p:cNvSpPr/>
-          <p:nvPr/>
-        </p:nvSpPr>
-        <p:spPr>
-          <a:xfrm>
-            <a:off x="4724400" y="2997200"/>
-            <a:ext cx="4064000" cy="12700"/>
-          </a:xfrm>
-          <a:prstGeom prst="rect">
-            <a:avLst/>
-          </a:prstGeom>
-          <a:solidFill>
-            <a:srgbClr val="FF6F03"/>
-          </a:solidFill>
-          <a:ln>
-            <a:noFill/>
-          </a:ln>
-        </p:spPr>
-        <p:txBody>
-          <a:bodyPr rtlCol="0" anchor="ctr"/>
-          <a:lstStyle/>
-          <a:p>
-            <a:pPr algn="ctr"/>
-          </a:p>
-        </p:txBody>
-      </p:sp>
-      <p:sp>
-        <p:nvSpPr>
-          <p:cNvPr id="15" name="TextBox 14"/>
-          <p:cNvSpPr txBox="1"/>
-          <p:nvPr/>
-        </p:nvSpPr>
-        <p:spPr>
-          <a:xfrm>
-            <a:off x="4724400" y="3098800"/>
-            <a:ext cx="4064000" cy="1219200"/>
-          </a:xfrm>
-          <a:prstGeom prst="rect">
-            <a:avLst/>
-          </a:prstGeom>
-          <a:noFill/>
-        </p:spPr>
-        <p:txBody>
-          <a:bodyPr wrap="square" lIns="0" tIns="0" rIns="0" bIns="0">
-            <a:spAutoFit/>
-          </a:bodyPr>
-          <a:lstStyle/>
-          <a:p>
-            <a:pPr>
-              <a:spcAft>
-                <a:spcPts val="400"/>
-              </a:spcAft>
-            </a:pPr>
-            <a:r>
-              <a:rPr sz="850" b="1">
-                <a:solidFill>
-                  <a:srgbClr val="222222"/>
-                </a:solidFill>
-                <a:latin typeface="Inter"/>
-              </a:rPr>
-              <a:t>Ошибка: </a:t>
-            </a:r>
-            <a:r>
-              <a:rPr sz="850">
-                <a:solidFill>
-                  <a:srgbClr val="444444"/>
-                </a:solidFill>
-                <a:latin typeface="Inter"/>
-              </a:rPr>
-              <a:t>Установка height: 100px для заголовка или списка оборудования приводит к обрезанию или вылезанию текста наружу.</a:t>
-            </a:r>
-          </a:p>
-          <a:p>
-            <a:pPr>
-              <a:lnSpc>
-                <a:spcPct val="115000"/>
-              </a:lnSpc>
-              <a:spcAft>
-                <a:spcPts val="0"/>
-              </a:spcAft>
-            </a:pPr>
-            <a:r>
-              <a:rPr sz="850" b="1">
-                <a:solidFill>
-                  <a:srgbClr val="16A34A"/>
-                </a:solidFill>
-                <a:latin typeface="Inter"/>
-              </a:rPr>
-              <a:t>Решение: </a:t>
-            </a:r>
-            <a:r>
-              <a:rPr sz="850">
-                <a:solidFill>
-                  <a:srgbClr val="444444"/>
-                </a:solidFill>
-                <a:latin typeface="Inter"/>
-              </a:rPr>
-              <a:t>Задавать только min-height, либо позволять флекс-распоркам автоматически распределять высоту по контенту.</a:t>
-            </a:r>
-          </a:p>
-        </p:txBody>
-      </p:sp>
-    </p:spTree>
-  </p:cSld>
-  <p:clrMapOvr>
-    <a:masterClrMapping/>
-  </p:clrMapOvr>
-</p:sld>
-</file>
-
-<file path=ppt/slides/slide49.xml><?xml version="1.0" encoding="utf-8"?>
 <p:sld xmlns:a="http://schemas.openxmlformats.org/drawingml/2006/main" xmlns:p="http://schemas.openxmlformats.org/presentationml/2006/main" xmlns:r="http://schemas.openxmlformats.org/officeDocument/2006/relationships">
   <p:cSld>
     <p:spTree>

</xml_diff>